<commit_message>
Add Speedrun deck v2/v3 and updated BOOST7 deck
</commit_message>
<xml_diff>
--- a/BidIntell_BOOST7_v7.pptx
+++ b/BidIntell_BOOST7_v7.pptx
@@ -122,23 +122,831 @@
 </p:presentation>
 </file>
 
+<file path=ppt/revisionInfo.xml><?xml version="1.0" encoding="utf-8"?>
+<p1510:revInfo xmlns:a="http://schemas.openxmlformats.org/drawingml/2006/main" xmlns:r="http://schemas.openxmlformats.org/officeDocument/2006/relationships" xmlns:p1510="http://schemas.microsoft.com/office/powerpoint/2015/10/main">
+  <p1510:revLst>
+    <p1510:client id="{AE89036F-DD11-445A-8B7F-8F50540066B9}" v="3" dt="2026-04-16T20:27:37.958"/>
+  </p1510:revLst>
+</p1510:revInfo>
+</file>
+
 <file path=ppt/changesInfos/changesInfo1.xml><?xml version="1.0" encoding="utf-8"?>
 <pc:chgInfo xmlns:a="http://schemas.openxmlformats.org/drawingml/2006/main" xmlns:r="http://schemas.openxmlformats.org/officeDocument/2006/relationships" xmlns:ac="http://schemas.microsoft.com/office/drawing/2013/main/command" xmlns:pc="http://schemas.microsoft.com/office/powerpoint/2013/main/command">
   <pc:docChgLst>
     <pc:chgData name="Ryan Elder" userId="0841b4ff-b127-4263-b5e2-9088e1f9be0c" providerId="ADAL" clId="{71BA6446-15FA-43EA-9A1D-A34ACCF7CF48}"/>
-    <pc:docChg chg="modSld">
-      <pc:chgData name="Ryan Elder" userId="0841b4ff-b127-4263-b5e2-9088e1f9be0c" providerId="ADAL" clId="{71BA6446-15FA-43EA-9A1D-A34ACCF7CF48}" dt="2026-04-10T21:36:03.440" v="7" actId="20577"/>
+    <pc:docChg chg="undo custSel modSld modMainMaster">
+      <pc:chgData name="Ryan Elder" userId="0841b4ff-b127-4263-b5e2-9088e1f9be0c" providerId="ADAL" clId="{71BA6446-15FA-43EA-9A1D-A34ACCF7CF48}" dt="2026-04-16T20:27:37.958" v="45"/>
       <pc:docMkLst>
         <pc:docMk/>
       </pc:docMkLst>
-      <pc:sldChg chg="modSp mod">
-        <pc:chgData name="Ryan Elder" userId="0841b4ff-b127-4263-b5e2-9088e1f9be0c" providerId="ADAL" clId="{71BA6446-15FA-43EA-9A1D-A34ACCF7CF48}" dt="2026-04-10T21:36:03.440" v="7" actId="20577"/>
+      <pc:sldChg chg="modSp setBg">
+        <pc:chgData name="Ryan Elder" userId="0841b4ff-b127-4263-b5e2-9088e1f9be0c" providerId="ADAL" clId="{71BA6446-15FA-43EA-9A1D-A34ACCF7CF48}" dt="2026-04-16T20:27:37.958" v="45"/>
+        <pc:sldMkLst>
+          <pc:docMk/>
+          <pc:sldMk cId="0" sldId="256"/>
+        </pc:sldMkLst>
+        <pc:spChg chg="mod">
+          <ac:chgData name="Ryan Elder" userId="0841b4ff-b127-4263-b5e2-9088e1f9be0c" providerId="ADAL" clId="{71BA6446-15FA-43EA-9A1D-A34ACCF7CF48}" dt="2026-04-16T20:27:28.581" v="44"/>
+          <ac:spMkLst>
+            <pc:docMk/>
+            <pc:sldMk cId="0" sldId="256"/>
+            <ac:spMk id="3" creationId="{00000000-0000-0000-0000-000000000000}"/>
+          </ac:spMkLst>
+        </pc:spChg>
+        <pc:spChg chg="mod">
+          <ac:chgData name="Ryan Elder" userId="0841b4ff-b127-4263-b5e2-9088e1f9be0c" providerId="ADAL" clId="{71BA6446-15FA-43EA-9A1D-A34ACCF7CF48}" dt="2026-04-16T20:27:28.581" v="44"/>
+          <ac:spMkLst>
+            <pc:docMk/>
+            <pc:sldMk cId="0" sldId="256"/>
+            <ac:spMk id="4" creationId="{00000000-0000-0000-0000-000000000000}"/>
+          </ac:spMkLst>
+        </pc:spChg>
+        <pc:spChg chg="mod">
+          <ac:chgData name="Ryan Elder" userId="0841b4ff-b127-4263-b5e2-9088e1f9be0c" providerId="ADAL" clId="{71BA6446-15FA-43EA-9A1D-A34ACCF7CF48}" dt="2026-04-16T20:27:28.581" v="44"/>
+          <ac:spMkLst>
+            <pc:docMk/>
+            <pc:sldMk cId="0" sldId="256"/>
+            <ac:spMk id="5" creationId="{00000000-0000-0000-0000-000000000000}"/>
+          </ac:spMkLst>
+        </pc:spChg>
+        <pc:spChg chg="mod">
+          <ac:chgData name="Ryan Elder" userId="0841b4ff-b127-4263-b5e2-9088e1f9be0c" providerId="ADAL" clId="{71BA6446-15FA-43EA-9A1D-A34ACCF7CF48}" dt="2026-04-16T20:27:28.581" v="44"/>
+          <ac:spMkLst>
+            <pc:docMk/>
+            <pc:sldMk cId="0" sldId="256"/>
+            <ac:spMk id="10" creationId="{00000000-0000-0000-0000-000000000000}"/>
+          </ac:spMkLst>
+        </pc:spChg>
+        <pc:spChg chg="mod">
+          <ac:chgData name="Ryan Elder" userId="0841b4ff-b127-4263-b5e2-9088e1f9be0c" providerId="ADAL" clId="{71BA6446-15FA-43EA-9A1D-A34ACCF7CF48}" dt="2026-04-16T20:27:28.581" v="44"/>
+          <ac:spMkLst>
+            <pc:docMk/>
+            <pc:sldMk cId="0" sldId="256"/>
+            <ac:spMk id="11" creationId="{00000000-0000-0000-0000-000000000000}"/>
+          </ac:spMkLst>
+        </pc:spChg>
+        <pc:spChg chg="mod">
+          <ac:chgData name="Ryan Elder" userId="0841b4ff-b127-4263-b5e2-9088e1f9be0c" providerId="ADAL" clId="{71BA6446-15FA-43EA-9A1D-A34ACCF7CF48}" dt="2026-04-16T20:27:28.581" v="44"/>
+          <ac:spMkLst>
+            <pc:docMk/>
+            <pc:sldMk cId="0" sldId="256"/>
+            <ac:spMk id="12" creationId="{00000000-0000-0000-0000-000000000000}"/>
+          </ac:spMkLst>
+        </pc:spChg>
+        <pc:spChg chg="mod">
+          <ac:chgData name="Ryan Elder" userId="0841b4ff-b127-4263-b5e2-9088e1f9be0c" providerId="ADAL" clId="{71BA6446-15FA-43EA-9A1D-A34ACCF7CF48}" dt="2026-04-16T20:27:28.581" v="44"/>
+          <ac:spMkLst>
+            <pc:docMk/>
+            <pc:sldMk cId="0" sldId="256"/>
+            <ac:spMk id="13" creationId="{00000000-0000-0000-0000-000000000000}"/>
+          </ac:spMkLst>
+        </pc:spChg>
+        <pc:spChg chg="mod">
+          <ac:chgData name="Ryan Elder" userId="0841b4ff-b127-4263-b5e2-9088e1f9be0c" providerId="ADAL" clId="{71BA6446-15FA-43EA-9A1D-A34ACCF7CF48}" dt="2026-04-16T20:27:28.581" v="44"/>
+          <ac:spMkLst>
+            <pc:docMk/>
+            <pc:sldMk cId="0" sldId="256"/>
+            <ac:spMk id="15" creationId="{00000000-0000-0000-0000-000000000000}"/>
+          </ac:spMkLst>
+        </pc:spChg>
+        <pc:spChg chg="mod">
+          <ac:chgData name="Ryan Elder" userId="0841b4ff-b127-4263-b5e2-9088e1f9be0c" providerId="ADAL" clId="{71BA6446-15FA-43EA-9A1D-A34ACCF7CF48}" dt="2026-04-16T20:27:28.581" v="44"/>
+          <ac:spMkLst>
+            <pc:docMk/>
+            <pc:sldMk cId="0" sldId="256"/>
+            <ac:spMk id="17" creationId="{00000000-0000-0000-0000-000000000000}"/>
+          </ac:spMkLst>
+        </pc:spChg>
+        <pc:spChg chg="mod">
+          <ac:chgData name="Ryan Elder" userId="0841b4ff-b127-4263-b5e2-9088e1f9be0c" providerId="ADAL" clId="{71BA6446-15FA-43EA-9A1D-A34ACCF7CF48}" dt="2026-04-16T20:27:28.581" v="44"/>
+          <ac:spMkLst>
+            <pc:docMk/>
+            <pc:sldMk cId="0" sldId="256"/>
+            <ac:spMk id="18" creationId="{00000000-0000-0000-0000-000000000000}"/>
+          </ac:spMkLst>
+        </pc:spChg>
+      </pc:sldChg>
+      <pc:sldChg chg="modSp setBg">
+        <pc:chgData name="Ryan Elder" userId="0841b4ff-b127-4263-b5e2-9088e1f9be0c" providerId="ADAL" clId="{71BA6446-15FA-43EA-9A1D-A34ACCF7CF48}" dt="2026-04-16T20:27:37.958" v="45"/>
+        <pc:sldMkLst>
+          <pc:docMk/>
+          <pc:sldMk cId="0" sldId="257"/>
+        </pc:sldMkLst>
+        <pc:spChg chg="mod">
+          <ac:chgData name="Ryan Elder" userId="0841b4ff-b127-4263-b5e2-9088e1f9be0c" providerId="ADAL" clId="{71BA6446-15FA-43EA-9A1D-A34ACCF7CF48}" dt="2026-04-16T20:27:28.581" v="44"/>
+          <ac:spMkLst>
+            <pc:docMk/>
+            <pc:sldMk cId="0" sldId="257"/>
+            <ac:spMk id="2" creationId="{00000000-0000-0000-0000-000000000000}"/>
+          </ac:spMkLst>
+        </pc:spChg>
+        <pc:spChg chg="mod">
+          <ac:chgData name="Ryan Elder" userId="0841b4ff-b127-4263-b5e2-9088e1f9be0c" providerId="ADAL" clId="{71BA6446-15FA-43EA-9A1D-A34ACCF7CF48}" dt="2026-04-16T20:27:28.581" v="44"/>
+          <ac:spMkLst>
+            <pc:docMk/>
+            <pc:sldMk cId="0" sldId="257"/>
+            <ac:spMk id="4" creationId="{00000000-0000-0000-0000-000000000000}"/>
+          </ac:spMkLst>
+        </pc:spChg>
+        <pc:spChg chg="mod">
+          <ac:chgData name="Ryan Elder" userId="0841b4ff-b127-4263-b5e2-9088e1f9be0c" providerId="ADAL" clId="{71BA6446-15FA-43EA-9A1D-A34ACCF7CF48}" dt="2026-04-16T20:27:28.581" v="44"/>
+          <ac:spMkLst>
+            <pc:docMk/>
+            <pc:sldMk cId="0" sldId="257"/>
+            <ac:spMk id="5" creationId="{00000000-0000-0000-0000-000000000000}"/>
+          </ac:spMkLst>
+        </pc:spChg>
+        <pc:spChg chg="mod">
+          <ac:chgData name="Ryan Elder" userId="0841b4ff-b127-4263-b5e2-9088e1f9be0c" providerId="ADAL" clId="{71BA6446-15FA-43EA-9A1D-A34ACCF7CF48}" dt="2026-04-16T20:27:28.581" v="44"/>
+          <ac:spMkLst>
+            <pc:docMk/>
+            <pc:sldMk cId="0" sldId="257"/>
+            <ac:spMk id="6" creationId="{00000000-0000-0000-0000-000000000000}"/>
+          </ac:spMkLst>
+        </pc:spChg>
+        <pc:spChg chg="mod">
+          <ac:chgData name="Ryan Elder" userId="0841b4ff-b127-4263-b5e2-9088e1f9be0c" providerId="ADAL" clId="{71BA6446-15FA-43EA-9A1D-A34ACCF7CF48}" dt="2026-04-16T20:27:28.581" v="44"/>
+          <ac:spMkLst>
+            <pc:docMk/>
+            <pc:sldMk cId="0" sldId="257"/>
+            <ac:spMk id="8" creationId="{00000000-0000-0000-0000-000000000000}"/>
+          </ac:spMkLst>
+        </pc:spChg>
+        <pc:spChg chg="mod">
+          <ac:chgData name="Ryan Elder" userId="0841b4ff-b127-4263-b5e2-9088e1f9be0c" providerId="ADAL" clId="{71BA6446-15FA-43EA-9A1D-A34ACCF7CF48}" dt="2026-04-16T20:27:28.581" v="44"/>
+          <ac:spMkLst>
+            <pc:docMk/>
+            <pc:sldMk cId="0" sldId="257"/>
+            <ac:spMk id="9" creationId="{00000000-0000-0000-0000-000000000000}"/>
+          </ac:spMkLst>
+        </pc:spChg>
+        <pc:spChg chg="mod">
+          <ac:chgData name="Ryan Elder" userId="0841b4ff-b127-4263-b5e2-9088e1f9be0c" providerId="ADAL" clId="{71BA6446-15FA-43EA-9A1D-A34ACCF7CF48}" dt="2026-04-16T20:27:28.581" v="44"/>
+          <ac:spMkLst>
+            <pc:docMk/>
+            <pc:sldMk cId="0" sldId="257"/>
+            <ac:spMk id="11" creationId="{00000000-0000-0000-0000-000000000000}"/>
+          </ac:spMkLst>
+        </pc:spChg>
+        <pc:spChg chg="mod">
+          <ac:chgData name="Ryan Elder" userId="0841b4ff-b127-4263-b5e2-9088e1f9be0c" providerId="ADAL" clId="{71BA6446-15FA-43EA-9A1D-A34ACCF7CF48}" dt="2026-04-16T20:27:28.581" v="44"/>
+          <ac:spMkLst>
+            <pc:docMk/>
+            <pc:sldMk cId="0" sldId="257"/>
+            <ac:spMk id="18" creationId="{00000000-0000-0000-0000-000000000000}"/>
+          </ac:spMkLst>
+        </pc:spChg>
+        <pc:spChg chg="mod">
+          <ac:chgData name="Ryan Elder" userId="0841b4ff-b127-4263-b5e2-9088e1f9be0c" providerId="ADAL" clId="{71BA6446-15FA-43EA-9A1D-A34ACCF7CF48}" dt="2026-04-16T20:27:28.581" v="44"/>
+          <ac:spMkLst>
+            <pc:docMk/>
+            <pc:sldMk cId="0" sldId="257"/>
+            <ac:spMk id="19" creationId="{00000000-0000-0000-0000-000000000000}"/>
+          </ac:spMkLst>
+        </pc:spChg>
+        <pc:spChg chg="mod">
+          <ac:chgData name="Ryan Elder" userId="0841b4ff-b127-4263-b5e2-9088e1f9be0c" providerId="ADAL" clId="{71BA6446-15FA-43EA-9A1D-A34ACCF7CF48}" dt="2026-04-16T20:27:28.581" v="44"/>
+          <ac:spMkLst>
+            <pc:docMk/>
+            <pc:sldMk cId="0" sldId="257"/>
+            <ac:spMk id="20" creationId="{00000000-0000-0000-0000-000000000000}"/>
+          </ac:spMkLst>
+        </pc:spChg>
+      </pc:sldChg>
+      <pc:sldChg chg="modSp mod setBg">
+        <pc:chgData name="Ryan Elder" userId="0841b4ff-b127-4263-b5e2-9088e1f9be0c" providerId="ADAL" clId="{71BA6446-15FA-43EA-9A1D-A34ACCF7CF48}" dt="2026-04-16T20:27:37.958" v="45"/>
+        <pc:sldMkLst>
+          <pc:docMk/>
+          <pc:sldMk cId="0" sldId="258"/>
+        </pc:sldMkLst>
+        <pc:spChg chg="mod">
+          <ac:chgData name="Ryan Elder" userId="0841b4ff-b127-4263-b5e2-9088e1f9be0c" providerId="ADAL" clId="{71BA6446-15FA-43EA-9A1D-A34ACCF7CF48}" dt="2026-04-16T20:27:28.581" v="44"/>
+          <ac:spMkLst>
+            <pc:docMk/>
+            <pc:sldMk cId="0" sldId="258"/>
+            <ac:spMk id="2" creationId="{00000000-0000-0000-0000-000000000000}"/>
+          </ac:spMkLst>
+        </pc:spChg>
+        <pc:spChg chg="mod">
+          <ac:chgData name="Ryan Elder" userId="0841b4ff-b127-4263-b5e2-9088e1f9be0c" providerId="ADAL" clId="{71BA6446-15FA-43EA-9A1D-A34ACCF7CF48}" dt="2026-04-16T20:27:28.581" v="44"/>
+          <ac:spMkLst>
+            <pc:docMk/>
+            <pc:sldMk cId="0" sldId="258"/>
+            <ac:spMk id="7" creationId="{00000000-0000-0000-0000-000000000000}"/>
+          </ac:spMkLst>
+        </pc:spChg>
+        <pc:spChg chg="mod">
+          <ac:chgData name="Ryan Elder" userId="0841b4ff-b127-4263-b5e2-9088e1f9be0c" providerId="ADAL" clId="{71BA6446-15FA-43EA-9A1D-A34ACCF7CF48}" dt="2026-04-16T20:27:28.581" v="44"/>
+          <ac:spMkLst>
+            <pc:docMk/>
+            <pc:sldMk cId="0" sldId="258"/>
+            <ac:spMk id="8" creationId="{00000000-0000-0000-0000-000000000000}"/>
+          </ac:spMkLst>
+        </pc:spChg>
+        <pc:spChg chg="mod">
+          <ac:chgData name="Ryan Elder" userId="0841b4ff-b127-4263-b5e2-9088e1f9be0c" providerId="ADAL" clId="{71BA6446-15FA-43EA-9A1D-A34ACCF7CF48}" dt="2026-04-16T20:27:28.581" v="44"/>
+          <ac:spMkLst>
+            <pc:docMk/>
+            <pc:sldMk cId="0" sldId="258"/>
+            <ac:spMk id="11" creationId="{00000000-0000-0000-0000-000000000000}"/>
+          </ac:spMkLst>
+        </pc:spChg>
+        <pc:spChg chg="mod">
+          <ac:chgData name="Ryan Elder" userId="0841b4ff-b127-4263-b5e2-9088e1f9be0c" providerId="ADAL" clId="{71BA6446-15FA-43EA-9A1D-A34ACCF7CF48}" dt="2026-04-16T20:21:38" v="35" actId="20577"/>
+          <ac:spMkLst>
+            <pc:docMk/>
+            <pc:sldMk cId="0" sldId="258"/>
+            <ac:spMk id="14" creationId="{00000000-0000-0000-0000-000000000000}"/>
+          </ac:spMkLst>
+        </pc:spChg>
+        <pc:spChg chg="mod">
+          <ac:chgData name="Ryan Elder" userId="0841b4ff-b127-4263-b5e2-9088e1f9be0c" providerId="ADAL" clId="{71BA6446-15FA-43EA-9A1D-A34ACCF7CF48}" dt="2026-04-16T20:27:28.581" v="44"/>
+          <ac:spMkLst>
+            <pc:docMk/>
+            <pc:sldMk cId="0" sldId="258"/>
+            <ac:spMk id="21" creationId="{00000000-0000-0000-0000-000000000000}"/>
+          </ac:spMkLst>
+        </pc:spChg>
+        <pc:spChg chg="mod">
+          <ac:chgData name="Ryan Elder" userId="0841b4ff-b127-4263-b5e2-9088e1f9be0c" providerId="ADAL" clId="{71BA6446-15FA-43EA-9A1D-A34ACCF7CF48}" dt="2026-04-16T20:27:28.581" v="44"/>
+          <ac:spMkLst>
+            <pc:docMk/>
+            <pc:sldMk cId="0" sldId="258"/>
+            <ac:spMk id="27" creationId="{00000000-0000-0000-0000-000000000000}"/>
+          </ac:spMkLst>
+        </pc:spChg>
+        <pc:spChg chg="mod">
+          <ac:chgData name="Ryan Elder" userId="0841b4ff-b127-4263-b5e2-9088e1f9be0c" providerId="ADAL" clId="{71BA6446-15FA-43EA-9A1D-A34ACCF7CF48}" dt="2026-04-16T20:27:28.581" v="44"/>
+          <ac:spMkLst>
+            <pc:docMk/>
+            <pc:sldMk cId="0" sldId="258"/>
+            <ac:spMk id="29" creationId="{00000000-0000-0000-0000-000000000000}"/>
+          </ac:spMkLst>
+        </pc:spChg>
+        <pc:spChg chg="mod">
+          <ac:chgData name="Ryan Elder" userId="0841b4ff-b127-4263-b5e2-9088e1f9be0c" providerId="ADAL" clId="{71BA6446-15FA-43EA-9A1D-A34ACCF7CF48}" dt="2026-04-16T20:27:28.581" v="44"/>
+          <ac:spMkLst>
+            <pc:docMk/>
+            <pc:sldMk cId="0" sldId="258"/>
+            <ac:spMk id="46" creationId="{00000000-0000-0000-0000-000000000000}"/>
+          </ac:spMkLst>
+        </pc:spChg>
+        <pc:spChg chg="mod">
+          <ac:chgData name="Ryan Elder" userId="0841b4ff-b127-4263-b5e2-9088e1f9be0c" providerId="ADAL" clId="{71BA6446-15FA-43EA-9A1D-A34ACCF7CF48}" dt="2026-04-16T20:27:28.581" v="44"/>
+          <ac:spMkLst>
+            <pc:docMk/>
+            <pc:sldMk cId="0" sldId="258"/>
+            <ac:spMk id="49" creationId="{00000000-0000-0000-0000-000000000000}"/>
+          </ac:spMkLst>
+        </pc:spChg>
+        <pc:spChg chg="mod">
+          <ac:chgData name="Ryan Elder" userId="0841b4ff-b127-4263-b5e2-9088e1f9be0c" providerId="ADAL" clId="{71BA6446-15FA-43EA-9A1D-A34ACCF7CF48}" dt="2026-04-16T20:27:28.581" v="44"/>
+          <ac:spMkLst>
+            <pc:docMk/>
+            <pc:sldMk cId="0" sldId="258"/>
+            <ac:spMk id="51" creationId="{00000000-0000-0000-0000-000000000000}"/>
+          </ac:spMkLst>
+        </pc:spChg>
+        <pc:spChg chg="mod">
+          <ac:chgData name="Ryan Elder" userId="0841b4ff-b127-4263-b5e2-9088e1f9be0c" providerId="ADAL" clId="{71BA6446-15FA-43EA-9A1D-A34ACCF7CF48}" dt="2026-04-16T20:22:29.573" v="37" actId="1076"/>
+          <ac:spMkLst>
+            <pc:docMk/>
+            <pc:sldMk cId="0" sldId="258"/>
+            <ac:spMk id="55" creationId="{00000000-0000-0000-0000-000000000000}"/>
+          </ac:spMkLst>
+        </pc:spChg>
+      </pc:sldChg>
+      <pc:sldChg chg="modSp setBg">
+        <pc:chgData name="Ryan Elder" userId="0841b4ff-b127-4263-b5e2-9088e1f9be0c" providerId="ADAL" clId="{71BA6446-15FA-43EA-9A1D-A34ACCF7CF48}" dt="2026-04-16T20:27:37.958" v="45"/>
+        <pc:sldMkLst>
+          <pc:docMk/>
+          <pc:sldMk cId="0" sldId="259"/>
+        </pc:sldMkLst>
+        <pc:spChg chg="mod">
+          <ac:chgData name="Ryan Elder" userId="0841b4ff-b127-4263-b5e2-9088e1f9be0c" providerId="ADAL" clId="{71BA6446-15FA-43EA-9A1D-A34ACCF7CF48}" dt="2026-04-16T20:27:28.581" v="44"/>
+          <ac:spMkLst>
+            <pc:docMk/>
+            <pc:sldMk cId="0" sldId="259"/>
+            <ac:spMk id="2" creationId="{00000000-0000-0000-0000-000000000000}"/>
+          </ac:spMkLst>
+        </pc:spChg>
+        <pc:spChg chg="mod">
+          <ac:chgData name="Ryan Elder" userId="0841b4ff-b127-4263-b5e2-9088e1f9be0c" providerId="ADAL" clId="{71BA6446-15FA-43EA-9A1D-A34ACCF7CF48}" dt="2026-04-16T20:27:28.581" v="44"/>
+          <ac:spMkLst>
+            <pc:docMk/>
+            <pc:sldMk cId="0" sldId="259"/>
+            <ac:spMk id="8" creationId="{00000000-0000-0000-0000-000000000000}"/>
+          </ac:spMkLst>
+        </pc:spChg>
+        <pc:spChg chg="mod">
+          <ac:chgData name="Ryan Elder" userId="0841b4ff-b127-4263-b5e2-9088e1f9be0c" providerId="ADAL" clId="{71BA6446-15FA-43EA-9A1D-A34ACCF7CF48}" dt="2026-04-16T20:27:28.581" v="44"/>
+          <ac:spMkLst>
+            <pc:docMk/>
+            <pc:sldMk cId="0" sldId="259"/>
+            <ac:spMk id="9" creationId="{00000000-0000-0000-0000-000000000000}"/>
+          </ac:spMkLst>
+        </pc:spChg>
+        <pc:spChg chg="mod">
+          <ac:chgData name="Ryan Elder" userId="0841b4ff-b127-4263-b5e2-9088e1f9be0c" providerId="ADAL" clId="{71BA6446-15FA-43EA-9A1D-A34ACCF7CF48}" dt="2026-04-16T20:27:28.581" v="44"/>
+          <ac:spMkLst>
+            <pc:docMk/>
+            <pc:sldMk cId="0" sldId="259"/>
+            <ac:spMk id="10" creationId="{00000000-0000-0000-0000-000000000000}"/>
+          </ac:spMkLst>
+        </pc:spChg>
+        <pc:spChg chg="mod">
+          <ac:chgData name="Ryan Elder" userId="0841b4ff-b127-4263-b5e2-9088e1f9be0c" providerId="ADAL" clId="{71BA6446-15FA-43EA-9A1D-A34ACCF7CF48}" dt="2026-04-16T20:27:28.581" v="44"/>
+          <ac:spMkLst>
+            <pc:docMk/>
+            <pc:sldMk cId="0" sldId="259"/>
+            <ac:spMk id="11" creationId="{00000000-0000-0000-0000-000000000000}"/>
+          </ac:spMkLst>
+        </pc:spChg>
+        <pc:spChg chg="mod">
+          <ac:chgData name="Ryan Elder" userId="0841b4ff-b127-4263-b5e2-9088e1f9be0c" providerId="ADAL" clId="{71BA6446-15FA-43EA-9A1D-A34ACCF7CF48}" dt="2026-04-16T20:27:28.581" v="44"/>
+          <ac:spMkLst>
+            <pc:docMk/>
+            <pc:sldMk cId="0" sldId="259"/>
+            <ac:spMk id="14" creationId="{00000000-0000-0000-0000-000000000000}"/>
+          </ac:spMkLst>
+        </pc:spChg>
+        <pc:spChg chg="mod">
+          <ac:chgData name="Ryan Elder" userId="0841b4ff-b127-4263-b5e2-9088e1f9be0c" providerId="ADAL" clId="{71BA6446-15FA-43EA-9A1D-A34ACCF7CF48}" dt="2026-04-16T20:27:28.581" v="44"/>
+          <ac:spMkLst>
+            <pc:docMk/>
+            <pc:sldMk cId="0" sldId="259"/>
+            <ac:spMk id="16" creationId="{00000000-0000-0000-0000-000000000000}"/>
+          </ac:spMkLst>
+        </pc:spChg>
+        <pc:spChg chg="mod">
+          <ac:chgData name="Ryan Elder" userId="0841b4ff-b127-4263-b5e2-9088e1f9be0c" providerId="ADAL" clId="{71BA6446-15FA-43EA-9A1D-A34ACCF7CF48}" dt="2026-04-16T20:27:28.581" v="44"/>
+          <ac:spMkLst>
+            <pc:docMk/>
+            <pc:sldMk cId="0" sldId="259"/>
+            <ac:spMk id="18" creationId="{00000000-0000-0000-0000-000000000000}"/>
+          </ac:spMkLst>
+        </pc:spChg>
+        <pc:spChg chg="mod">
+          <ac:chgData name="Ryan Elder" userId="0841b4ff-b127-4263-b5e2-9088e1f9be0c" providerId="ADAL" clId="{71BA6446-15FA-43EA-9A1D-A34ACCF7CF48}" dt="2026-04-16T20:27:28.581" v="44"/>
+          <ac:spMkLst>
+            <pc:docMk/>
+            <pc:sldMk cId="0" sldId="259"/>
+            <ac:spMk id="21" creationId="{00000000-0000-0000-0000-000000000000}"/>
+          </ac:spMkLst>
+        </pc:spChg>
+        <pc:spChg chg="mod">
+          <ac:chgData name="Ryan Elder" userId="0841b4ff-b127-4263-b5e2-9088e1f9be0c" providerId="ADAL" clId="{71BA6446-15FA-43EA-9A1D-A34ACCF7CF48}" dt="2026-04-16T20:27:28.581" v="44"/>
+          <ac:spMkLst>
+            <pc:docMk/>
+            <pc:sldMk cId="0" sldId="259"/>
+            <ac:spMk id="27" creationId="{00000000-0000-0000-0000-000000000000}"/>
+          </ac:spMkLst>
+        </pc:spChg>
+      </pc:sldChg>
+      <pc:sldChg chg="delSp modSp mod setBg">
+        <pc:chgData name="Ryan Elder" userId="0841b4ff-b127-4263-b5e2-9088e1f9be0c" providerId="ADAL" clId="{71BA6446-15FA-43EA-9A1D-A34ACCF7CF48}" dt="2026-04-16T20:27:37.958" v="45"/>
+        <pc:sldMkLst>
+          <pc:docMk/>
+          <pc:sldMk cId="0" sldId="260"/>
+        </pc:sldMkLst>
+        <pc:spChg chg="mod">
+          <ac:chgData name="Ryan Elder" userId="0841b4ff-b127-4263-b5e2-9088e1f9be0c" providerId="ADAL" clId="{71BA6446-15FA-43EA-9A1D-A34ACCF7CF48}" dt="2026-04-16T20:27:28.581" v="44"/>
+          <ac:spMkLst>
+            <pc:docMk/>
+            <pc:sldMk cId="0" sldId="260"/>
+            <ac:spMk id="2" creationId="{00000000-0000-0000-0000-000000000000}"/>
+          </ac:spMkLst>
+        </pc:spChg>
+        <pc:spChg chg="mod">
+          <ac:chgData name="Ryan Elder" userId="0841b4ff-b127-4263-b5e2-9088e1f9be0c" providerId="ADAL" clId="{71BA6446-15FA-43EA-9A1D-A34ACCF7CF48}" dt="2026-04-16T20:27:28.581" v="44"/>
+          <ac:spMkLst>
+            <pc:docMk/>
+            <pc:sldMk cId="0" sldId="260"/>
+            <ac:spMk id="10" creationId="{00000000-0000-0000-0000-000000000000}"/>
+          </ac:spMkLst>
+        </pc:spChg>
+        <pc:spChg chg="mod">
+          <ac:chgData name="Ryan Elder" userId="0841b4ff-b127-4263-b5e2-9088e1f9be0c" providerId="ADAL" clId="{71BA6446-15FA-43EA-9A1D-A34ACCF7CF48}" dt="2026-04-16T20:27:28.581" v="44"/>
+          <ac:spMkLst>
+            <pc:docMk/>
+            <pc:sldMk cId="0" sldId="260"/>
+            <ac:spMk id="13" creationId="{00000000-0000-0000-0000-000000000000}"/>
+          </ac:spMkLst>
+        </pc:spChg>
+        <pc:spChg chg="mod">
+          <ac:chgData name="Ryan Elder" userId="0841b4ff-b127-4263-b5e2-9088e1f9be0c" providerId="ADAL" clId="{71BA6446-15FA-43EA-9A1D-A34ACCF7CF48}" dt="2026-04-16T20:27:28.581" v="44"/>
+          <ac:spMkLst>
+            <pc:docMk/>
+            <pc:sldMk cId="0" sldId="260"/>
+            <ac:spMk id="15" creationId="{00000000-0000-0000-0000-000000000000}"/>
+          </ac:spMkLst>
+        </pc:spChg>
+        <pc:spChg chg="mod">
+          <ac:chgData name="Ryan Elder" userId="0841b4ff-b127-4263-b5e2-9088e1f9be0c" providerId="ADAL" clId="{71BA6446-15FA-43EA-9A1D-A34ACCF7CF48}" dt="2026-04-16T20:27:28.581" v="44"/>
+          <ac:spMkLst>
+            <pc:docMk/>
+            <pc:sldMk cId="0" sldId="260"/>
+            <ac:spMk id="18" creationId="{00000000-0000-0000-0000-000000000000}"/>
+          </ac:spMkLst>
+        </pc:spChg>
+        <pc:spChg chg="mod">
+          <ac:chgData name="Ryan Elder" userId="0841b4ff-b127-4263-b5e2-9088e1f9be0c" providerId="ADAL" clId="{71BA6446-15FA-43EA-9A1D-A34ACCF7CF48}" dt="2026-04-16T20:27:28.581" v="44"/>
+          <ac:spMkLst>
+            <pc:docMk/>
+            <pc:sldMk cId="0" sldId="260"/>
+            <ac:spMk id="22" creationId="{00000000-0000-0000-0000-000000000000}"/>
+          </ac:spMkLst>
+        </pc:spChg>
+        <pc:spChg chg="del mod">
+          <ac:chgData name="Ryan Elder" userId="0841b4ff-b127-4263-b5e2-9088e1f9be0c" providerId="ADAL" clId="{71BA6446-15FA-43EA-9A1D-A34ACCF7CF48}" dt="2026-04-16T20:22:43.791" v="39" actId="478"/>
+          <ac:spMkLst>
+            <pc:docMk/>
+            <pc:sldMk cId="0" sldId="260"/>
+            <ac:spMk id="25" creationId="{00000000-0000-0000-0000-000000000000}"/>
+          </ac:spMkLst>
+        </pc:spChg>
+        <pc:spChg chg="mod">
+          <ac:chgData name="Ryan Elder" userId="0841b4ff-b127-4263-b5e2-9088e1f9be0c" providerId="ADAL" clId="{71BA6446-15FA-43EA-9A1D-A34ACCF7CF48}" dt="2026-04-16T20:27:28.581" v="44"/>
+          <ac:spMkLst>
+            <pc:docMk/>
+            <pc:sldMk cId="0" sldId="260"/>
+            <ac:spMk id="38" creationId="{00000000-0000-0000-0000-000000000000}"/>
+          </ac:spMkLst>
+        </pc:spChg>
+        <pc:spChg chg="del">
+          <ac:chgData name="Ryan Elder" userId="0841b4ff-b127-4263-b5e2-9088e1f9be0c" providerId="ADAL" clId="{71BA6446-15FA-43EA-9A1D-A34ACCF7CF48}" dt="2026-04-16T20:22:48.095" v="40" actId="478"/>
+          <ac:spMkLst>
+            <pc:docMk/>
+            <pc:sldMk cId="0" sldId="260"/>
+            <ac:spMk id="39" creationId="{00000000-0000-0000-0000-000000000000}"/>
+          </ac:spMkLst>
+        </pc:spChg>
+        <pc:spChg chg="mod">
+          <ac:chgData name="Ryan Elder" userId="0841b4ff-b127-4263-b5e2-9088e1f9be0c" providerId="ADAL" clId="{71BA6446-15FA-43EA-9A1D-A34ACCF7CF48}" dt="2026-04-16T20:27:28.581" v="44"/>
+          <ac:spMkLst>
+            <pc:docMk/>
+            <pc:sldMk cId="0" sldId="260"/>
+            <ac:spMk id="41" creationId="{00000000-0000-0000-0000-000000000000}"/>
+          </ac:spMkLst>
+        </pc:spChg>
+        <pc:spChg chg="mod">
+          <ac:chgData name="Ryan Elder" userId="0841b4ff-b127-4263-b5e2-9088e1f9be0c" providerId="ADAL" clId="{71BA6446-15FA-43EA-9A1D-A34ACCF7CF48}" dt="2026-04-16T20:27:28.581" v="44"/>
+          <ac:spMkLst>
+            <pc:docMk/>
+            <pc:sldMk cId="0" sldId="260"/>
+            <ac:spMk id="45" creationId="{00000000-0000-0000-0000-000000000000}"/>
+          </ac:spMkLst>
+        </pc:spChg>
+        <pc:spChg chg="mod">
+          <ac:chgData name="Ryan Elder" userId="0841b4ff-b127-4263-b5e2-9088e1f9be0c" providerId="ADAL" clId="{71BA6446-15FA-43EA-9A1D-A34ACCF7CF48}" dt="2026-04-16T20:27:28.581" v="44"/>
+          <ac:spMkLst>
+            <pc:docMk/>
+            <pc:sldMk cId="0" sldId="260"/>
+            <ac:spMk id="47" creationId="{00000000-0000-0000-0000-000000000000}"/>
+          </ac:spMkLst>
+        </pc:spChg>
+      </pc:sldChg>
+      <pc:sldChg chg="modSp setBg">
+        <pc:chgData name="Ryan Elder" userId="0841b4ff-b127-4263-b5e2-9088e1f9be0c" providerId="ADAL" clId="{71BA6446-15FA-43EA-9A1D-A34ACCF7CF48}" dt="2026-04-16T20:27:37.958" v="45"/>
+        <pc:sldMkLst>
+          <pc:docMk/>
+          <pc:sldMk cId="0" sldId="261"/>
+        </pc:sldMkLst>
+        <pc:spChg chg="mod">
+          <ac:chgData name="Ryan Elder" userId="0841b4ff-b127-4263-b5e2-9088e1f9be0c" providerId="ADAL" clId="{71BA6446-15FA-43EA-9A1D-A34ACCF7CF48}" dt="2026-04-16T20:27:28.581" v="44"/>
+          <ac:spMkLst>
+            <pc:docMk/>
+            <pc:sldMk cId="0" sldId="261"/>
+            <ac:spMk id="4" creationId="{00000000-0000-0000-0000-000000000000}"/>
+          </ac:spMkLst>
+        </pc:spChg>
+        <pc:spChg chg="mod">
+          <ac:chgData name="Ryan Elder" userId="0841b4ff-b127-4263-b5e2-9088e1f9be0c" providerId="ADAL" clId="{71BA6446-15FA-43EA-9A1D-A34ACCF7CF48}" dt="2026-04-16T20:27:28.581" v="44"/>
+          <ac:spMkLst>
+            <pc:docMk/>
+            <pc:sldMk cId="0" sldId="261"/>
+            <ac:spMk id="5" creationId="{00000000-0000-0000-0000-000000000000}"/>
+          </ac:spMkLst>
+        </pc:spChg>
+        <pc:spChg chg="mod">
+          <ac:chgData name="Ryan Elder" userId="0841b4ff-b127-4263-b5e2-9088e1f9be0c" providerId="ADAL" clId="{71BA6446-15FA-43EA-9A1D-A34ACCF7CF48}" dt="2026-04-16T20:27:28.581" v="44"/>
+          <ac:spMkLst>
+            <pc:docMk/>
+            <pc:sldMk cId="0" sldId="261"/>
+            <ac:spMk id="6" creationId="{00000000-0000-0000-0000-000000000000}"/>
+          </ac:spMkLst>
+        </pc:spChg>
+        <pc:spChg chg="mod">
+          <ac:chgData name="Ryan Elder" userId="0841b4ff-b127-4263-b5e2-9088e1f9be0c" providerId="ADAL" clId="{71BA6446-15FA-43EA-9A1D-A34ACCF7CF48}" dt="2026-04-16T20:27:28.581" v="44"/>
+          <ac:spMkLst>
+            <pc:docMk/>
+            <pc:sldMk cId="0" sldId="261"/>
+            <ac:spMk id="7" creationId="{00000000-0000-0000-0000-000000000000}"/>
+          </ac:spMkLst>
+        </pc:spChg>
+        <pc:spChg chg="mod">
+          <ac:chgData name="Ryan Elder" userId="0841b4ff-b127-4263-b5e2-9088e1f9be0c" providerId="ADAL" clId="{71BA6446-15FA-43EA-9A1D-A34ACCF7CF48}" dt="2026-04-16T20:27:28.581" v="44"/>
+          <ac:spMkLst>
+            <pc:docMk/>
+            <pc:sldMk cId="0" sldId="261"/>
+            <ac:spMk id="15" creationId="{00000000-0000-0000-0000-000000000000}"/>
+          </ac:spMkLst>
+        </pc:spChg>
+        <pc:spChg chg="mod">
+          <ac:chgData name="Ryan Elder" userId="0841b4ff-b127-4263-b5e2-9088e1f9be0c" providerId="ADAL" clId="{71BA6446-15FA-43EA-9A1D-A34ACCF7CF48}" dt="2026-04-16T20:27:28.581" v="44"/>
+          <ac:spMkLst>
+            <pc:docMk/>
+            <pc:sldMk cId="0" sldId="261"/>
+            <ac:spMk id="18" creationId="{00000000-0000-0000-0000-000000000000}"/>
+          </ac:spMkLst>
+        </pc:spChg>
+        <pc:spChg chg="mod">
+          <ac:chgData name="Ryan Elder" userId="0841b4ff-b127-4263-b5e2-9088e1f9be0c" providerId="ADAL" clId="{71BA6446-15FA-43EA-9A1D-A34ACCF7CF48}" dt="2026-04-16T20:27:28.581" v="44"/>
+          <ac:spMkLst>
+            <pc:docMk/>
+            <pc:sldMk cId="0" sldId="261"/>
+            <ac:spMk id="22" creationId="{00000000-0000-0000-0000-000000000000}"/>
+          </ac:spMkLst>
+        </pc:spChg>
+        <pc:spChg chg="mod">
+          <ac:chgData name="Ryan Elder" userId="0841b4ff-b127-4263-b5e2-9088e1f9be0c" providerId="ADAL" clId="{71BA6446-15FA-43EA-9A1D-A34ACCF7CF48}" dt="2026-04-16T20:27:28.581" v="44"/>
+          <ac:spMkLst>
+            <pc:docMk/>
+            <pc:sldMk cId="0" sldId="261"/>
+            <ac:spMk id="33" creationId="{00000000-0000-0000-0000-000000000000}"/>
+          </ac:spMkLst>
+        </pc:spChg>
+        <pc:spChg chg="mod">
+          <ac:chgData name="Ryan Elder" userId="0841b4ff-b127-4263-b5e2-9088e1f9be0c" providerId="ADAL" clId="{71BA6446-15FA-43EA-9A1D-A34ACCF7CF48}" dt="2026-04-16T20:27:28.581" v="44"/>
+          <ac:spMkLst>
+            <pc:docMk/>
+            <pc:sldMk cId="0" sldId="261"/>
+            <ac:spMk id="34" creationId="{00000000-0000-0000-0000-000000000000}"/>
+          </ac:spMkLst>
+        </pc:spChg>
+        <pc:spChg chg="mod">
+          <ac:chgData name="Ryan Elder" userId="0841b4ff-b127-4263-b5e2-9088e1f9be0c" providerId="ADAL" clId="{71BA6446-15FA-43EA-9A1D-A34ACCF7CF48}" dt="2026-04-16T20:27:28.581" v="44"/>
+          <ac:spMkLst>
+            <pc:docMk/>
+            <pc:sldMk cId="0" sldId="261"/>
+            <ac:spMk id="35" creationId="{00000000-0000-0000-0000-000000000000}"/>
+          </ac:spMkLst>
+        </pc:spChg>
+      </pc:sldChg>
+      <pc:sldChg chg="modSp setBg">
+        <pc:chgData name="Ryan Elder" userId="0841b4ff-b127-4263-b5e2-9088e1f9be0c" providerId="ADAL" clId="{71BA6446-15FA-43EA-9A1D-A34ACCF7CF48}" dt="2026-04-16T20:27:37.958" v="45"/>
+        <pc:sldMkLst>
+          <pc:docMk/>
+          <pc:sldMk cId="0" sldId="262"/>
+        </pc:sldMkLst>
+        <pc:spChg chg="mod">
+          <ac:chgData name="Ryan Elder" userId="0841b4ff-b127-4263-b5e2-9088e1f9be0c" providerId="ADAL" clId="{71BA6446-15FA-43EA-9A1D-A34ACCF7CF48}" dt="2026-04-16T20:27:28.581" v="44"/>
+          <ac:spMkLst>
+            <pc:docMk/>
+            <pc:sldMk cId="0" sldId="262"/>
+            <ac:spMk id="4" creationId="{00000000-0000-0000-0000-000000000000}"/>
+          </ac:spMkLst>
+        </pc:spChg>
+        <pc:spChg chg="mod">
+          <ac:chgData name="Ryan Elder" userId="0841b4ff-b127-4263-b5e2-9088e1f9be0c" providerId="ADAL" clId="{71BA6446-15FA-43EA-9A1D-A34ACCF7CF48}" dt="2026-04-16T20:27:28.581" v="44"/>
+          <ac:spMkLst>
+            <pc:docMk/>
+            <pc:sldMk cId="0" sldId="262"/>
+            <ac:spMk id="11" creationId="{00000000-0000-0000-0000-000000000000}"/>
+          </ac:spMkLst>
+        </pc:spChg>
+        <pc:spChg chg="mod">
+          <ac:chgData name="Ryan Elder" userId="0841b4ff-b127-4263-b5e2-9088e1f9be0c" providerId="ADAL" clId="{71BA6446-15FA-43EA-9A1D-A34ACCF7CF48}" dt="2026-04-16T20:27:28.581" v="44"/>
+          <ac:spMkLst>
+            <pc:docMk/>
+            <pc:sldMk cId="0" sldId="262"/>
+            <ac:spMk id="12" creationId="{00000000-0000-0000-0000-000000000000}"/>
+          </ac:spMkLst>
+        </pc:spChg>
+        <pc:spChg chg="mod">
+          <ac:chgData name="Ryan Elder" userId="0841b4ff-b127-4263-b5e2-9088e1f9be0c" providerId="ADAL" clId="{71BA6446-15FA-43EA-9A1D-A34ACCF7CF48}" dt="2026-04-16T20:27:28.581" v="44"/>
+          <ac:spMkLst>
+            <pc:docMk/>
+            <pc:sldMk cId="0" sldId="262"/>
+            <ac:spMk id="13" creationId="{00000000-0000-0000-0000-000000000000}"/>
+          </ac:spMkLst>
+        </pc:spChg>
+        <pc:spChg chg="mod">
+          <ac:chgData name="Ryan Elder" userId="0841b4ff-b127-4263-b5e2-9088e1f9be0c" providerId="ADAL" clId="{71BA6446-15FA-43EA-9A1D-A34ACCF7CF48}" dt="2026-04-16T20:27:28.581" v="44"/>
+          <ac:spMkLst>
+            <pc:docMk/>
+            <pc:sldMk cId="0" sldId="262"/>
+            <ac:spMk id="17" creationId="{00000000-0000-0000-0000-000000000000}"/>
+          </ac:spMkLst>
+        </pc:spChg>
+        <pc:spChg chg="mod">
+          <ac:chgData name="Ryan Elder" userId="0841b4ff-b127-4263-b5e2-9088e1f9be0c" providerId="ADAL" clId="{71BA6446-15FA-43EA-9A1D-A34ACCF7CF48}" dt="2026-04-16T20:27:28.581" v="44"/>
+          <ac:spMkLst>
+            <pc:docMk/>
+            <pc:sldMk cId="0" sldId="262"/>
+            <ac:spMk id="19" creationId="{00000000-0000-0000-0000-000000000000}"/>
+          </ac:spMkLst>
+        </pc:spChg>
+        <pc:spChg chg="mod">
+          <ac:chgData name="Ryan Elder" userId="0841b4ff-b127-4263-b5e2-9088e1f9be0c" providerId="ADAL" clId="{71BA6446-15FA-43EA-9A1D-A34ACCF7CF48}" dt="2026-04-16T20:27:28.581" v="44"/>
+          <ac:spMkLst>
+            <pc:docMk/>
+            <pc:sldMk cId="0" sldId="262"/>
+            <ac:spMk id="26" creationId="{00000000-0000-0000-0000-000000000000}"/>
+          </ac:spMkLst>
+        </pc:spChg>
+        <pc:spChg chg="mod">
+          <ac:chgData name="Ryan Elder" userId="0841b4ff-b127-4263-b5e2-9088e1f9be0c" providerId="ADAL" clId="{71BA6446-15FA-43EA-9A1D-A34ACCF7CF48}" dt="2026-04-16T20:27:28.581" v="44"/>
+          <ac:spMkLst>
+            <pc:docMk/>
+            <pc:sldMk cId="0" sldId="262"/>
+            <ac:spMk id="32" creationId="{00000000-0000-0000-0000-000000000000}"/>
+          </ac:spMkLst>
+        </pc:spChg>
+        <pc:spChg chg="mod">
+          <ac:chgData name="Ryan Elder" userId="0841b4ff-b127-4263-b5e2-9088e1f9be0c" providerId="ADAL" clId="{71BA6446-15FA-43EA-9A1D-A34ACCF7CF48}" dt="2026-04-16T20:27:28.581" v="44"/>
+          <ac:spMkLst>
+            <pc:docMk/>
+            <pc:sldMk cId="0" sldId="262"/>
+            <ac:spMk id="42" creationId="{00000000-0000-0000-0000-000000000000}"/>
+          </ac:spMkLst>
+        </pc:spChg>
+        <pc:spChg chg="mod">
+          <ac:chgData name="Ryan Elder" userId="0841b4ff-b127-4263-b5e2-9088e1f9be0c" providerId="ADAL" clId="{71BA6446-15FA-43EA-9A1D-A34ACCF7CF48}" dt="2026-04-16T20:27:28.581" v="44"/>
+          <ac:spMkLst>
+            <pc:docMk/>
+            <pc:sldMk cId="0" sldId="262"/>
+            <ac:spMk id="46" creationId="{00000000-0000-0000-0000-000000000000}"/>
+          </ac:spMkLst>
+        </pc:spChg>
+      </pc:sldChg>
+      <pc:sldChg chg="modSp mod setBg">
+        <pc:chgData name="Ryan Elder" userId="0841b4ff-b127-4263-b5e2-9088e1f9be0c" providerId="ADAL" clId="{71BA6446-15FA-43EA-9A1D-A34ACCF7CF48}" dt="2026-04-16T20:27:37.958" v="45"/>
+        <pc:sldMkLst>
+          <pc:docMk/>
+          <pc:sldMk cId="0" sldId="263"/>
+        </pc:sldMkLst>
+        <pc:spChg chg="mod">
+          <ac:chgData name="Ryan Elder" userId="0841b4ff-b127-4263-b5e2-9088e1f9be0c" providerId="ADAL" clId="{71BA6446-15FA-43EA-9A1D-A34ACCF7CF48}" dt="2026-04-16T20:27:28.581" v="44"/>
+          <ac:spMkLst>
+            <pc:docMk/>
+            <pc:sldMk cId="0" sldId="263"/>
+            <ac:spMk id="2" creationId="{00000000-0000-0000-0000-000000000000}"/>
+          </ac:spMkLst>
+        </pc:spChg>
+        <pc:spChg chg="mod">
+          <ac:chgData name="Ryan Elder" userId="0841b4ff-b127-4263-b5e2-9088e1f9be0c" providerId="ADAL" clId="{71BA6446-15FA-43EA-9A1D-A34ACCF7CF48}" dt="2026-04-16T20:27:28.581" v="44"/>
+          <ac:spMkLst>
+            <pc:docMk/>
+            <pc:sldMk cId="0" sldId="263"/>
+            <ac:spMk id="5" creationId="{00000000-0000-0000-0000-000000000000}"/>
+          </ac:spMkLst>
+        </pc:spChg>
+        <pc:spChg chg="mod">
+          <ac:chgData name="Ryan Elder" userId="0841b4ff-b127-4263-b5e2-9088e1f9be0c" providerId="ADAL" clId="{71BA6446-15FA-43EA-9A1D-A34ACCF7CF48}" dt="2026-04-16T20:27:28.581" v="44"/>
+          <ac:spMkLst>
+            <pc:docMk/>
+            <pc:sldMk cId="0" sldId="263"/>
+            <ac:spMk id="16" creationId="{00000000-0000-0000-0000-000000000000}"/>
+          </ac:spMkLst>
+        </pc:spChg>
+        <pc:spChg chg="mod">
+          <ac:chgData name="Ryan Elder" userId="0841b4ff-b127-4263-b5e2-9088e1f9be0c" providerId="ADAL" clId="{71BA6446-15FA-43EA-9A1D-A34ACCF7CF48}" dt="2026-04-16T20:27:28.581" v="44"/>
+          <ac:spMkLst>
+            <pc:docMk/>
+            <pc:sldMk cId="0" sldId="263"/>
+            <ac:spMk id="23" creationId="{00000000-0000-0000-0000-000000000000}"/>
+          </ac:spMkLst>
+        </pc:spChg>
+        <pc:spChg chg="mod">
+          <ac:chgData name="Ryan Elder" userId="0841b4ff-b127-4263-b5e2-9088e1f9be0c" providerId="ADAL" clId="{71BA6446-15FA-43EA-9A1D-A34ACCF7CF48}" dt="2026-04-16T20:27:28.581" v="44"/>
+          <ac:spMkLst>
+            <pc:docMk/>
+            <pc:sldMk cId="0" sldId="263"/>
+            <ac:spMk id="24" creationId="{00000000-0000-0000-0000-000000000000}"/>
+          </ac:spMkLst>
+        </pc:spChg>
+        <pc:spChg chg="mod">
+          <ac:chgData name="Ryan Elder" userId="0841b4ff-b127-4263-b5e2-9088e1f9be0c" providerId="ADAL" clId="{71BA6446-15FA-43EA-9A1D-A34ACCF7CF48}" dt="2026-04-16T20:27:28.581" v="44"/>
+          <ac:spMkLst>
+            <pc:docMk/>
+            <pc:sldMk cId="0" sldId="263"/>
+            <ac:spMk id="26" creationId="{00000000-0000-0000-0000-000000000000}"/>
+          </ac:spMkLst>
+        </pc:spChg>
+        <pc:spChg chg="mod">
+          <ac:chgData name="Ryan Elder" userId="0841b4ff-b127-4263-b5e2-9088e1f9be0c" providerId="ADAL" clId="{71BA6446-15FA-43EA-9A1D-A34ACCF7CF48}" dt="2026-04-16T20:27:28.581" v="44"/>
+          <ac:spMkLst>
+            <pc:docMk/>
+            <pc:sldMk cId="0" sldId="263"/>
+            <ac:spMk id="36" creationId="{00000000-0000-0000-0000-000000000000}"/>
+          </ac:spMkLst>
+        </pc:spChg>
+        <pc:spChg chg="mod">
+          <ac:chgData name="Ryan Elder" userId="0841b4ff-b127-4263-b5e2-9088e1f9be0c" providerId="ADAL" clId="{71BA6446-15FA-43EA-9A1D-A34ACCF7CF48}" dt="2026-04-16T20:27:28.581" v="44"/>
+          <ac:spMkLst>
+            <pc:docMk/>
+            <pc:sldMk cId="0" sldId="263"/>
+            <ac:spMk id="38" creationId="{00000000-0000-0000-0000-000000000000}"/>
+          </ac:spMkLst>
+        </pc:spChg>
+        <pc:spChg chg="mod">
+          <ac:chgData name="Ryan Elder" userId="0841b4ff-b127-4263-b5e2-9088e1f9be0c" providerId="ADAL" clId="{71BA6446-15FA-43EA-9A1D-A34ACCF7CF48}" dt="2026-04-16T20:27:28.581" v="44"/>
+          <ac:spMkLst>
+            <pc:docMk/>
+            <pc:sldMk cId="0" sldId="263"/>
+            <ac:spMk id="41" creationId="{00000000-0000-0000-0000-000000000000}"/>
+          </ac:spMkLst>
+        </pc:spChg>
+        <pc:spChg chg="mod">
+          <ac:chgData name="Ryan Elder" userId="0841b4ff-b127-4263-b5e2-9088e1f9be0c" providerId="ADAL" clId="{71BA6446-15FA-43EA-9A1D-A34ACCF7CF48}" dt="2026-04-16T20:27:28.581" v="44"/>
+          <ac:spMkLst>
+            <pc:docMk/>
+            <pc:sldMk cId="0" sldId="263"/>
+            <ac:spMk id="44" creationId="{00000000-0000-0000-0000-000000000000}"/>
+          </ac:spMkLst>
+        </pc:spChg>
+      </pc:sldChg>
+      <pc:sldChg chg="modSp mod setBg">
+        <pc:chgData name="Ryan Elder" userId="0841b4ff-b127-4263-b5e2-9088e1f9be0c" providerId="ADAL" clId="{71BA6446-15FA-43EA-9A1D-A34ACCF7CF48}" dt="2026-04-16T20:27:37.958" v="45"/>
         <pc:sldMkLst>
           <pc:docMk/>
           <pc:sldMk cId="0" sldId="264"/>
         </pc:sldMkLst>
         <pc:spChg chg="mod">
-          <ac:chgData name="Ryan Elder" userId="0841b4ff-b127-4263-b5e2-9088e1f9be0c" providerId="ADAL" clId="{71BA6446-15FA-43EA-9A1D-A34ACCF7CF48}" dt="2026-04-10T21:36:03.440" v="7" actId="20577"/>
+          <ac:chgData name="Ryan Elder" userId="0841b4ff-b127-4263-b5e2-9088e1f9be0c" providerId="ADAL" clId="{71BA6446-15FA-43EA-9A1D-A34ACCF7CF48}" dt="2026-04-16T20:27:28.581" v="44"/>
+          <ac:spMkLst>
+            <pc:docMk/>
+            <pc:sldMk cId="0" sldId="264"/>
+            <ac:spMk id="3" creationId="{00000000-0000-0000-0000-000000000000}"/>
+          </ac:spMkLst>
+        </pc:spChg>
+        <pc:spChg chg="mod">
+          <ac:chgData name="Ryan Elder" userId="0841b4ff-b127-4263-b5e2-9088e1f9be0c" providerId="ADAL" clId="{71BA6446-15FA-43EA-9A1D-A34ACCF7CF48}" dt="2026-04-16T20:27:28.581" v="44"/>
+          <ac:spMkLst>
+            <pc:docMk/>
+            <pc:sldMk cId="0" sldId="264"/>
+            <ac:spMk id="4" creationId="{00000000-0000-0000-0000-000000000000}"/>
+          </ac:spMkLst>
+        </pc:spChg>
+        <pc:spChg chg="mod">
+          <ac:chgData name="Ryan Elder" userId="0841b4ff-b127-4263-b5e2-9088e1f9be0c" providerId="ADAL" clId="{71BA6446-15FA-43EA-9A1D-A34ACCF7CF48}" dt="2026-04-16T20:27:28.581" v="44"/>
+          <ac:spMkLst>
+            <pc:docMk/>
+            <pc:sldMk cId="0" sldId="264"/>
+            <ac:spMk id="10" creationId="{00000000-0000-0000-0000-000000000000}"/>
+          </ac:spMkLst>
+        </pc:spChg>
+        <pc:spChg chg="mod">
+          <ac:chgData name="Ryan Elder" userId="0841b4ff-b127-4263-b5e2-9088e1f9be0c" providerId="ADAL" clId="{71BA6446-15FA-43EA-9A1D-A34ACCF7CF48}" dt="2026-04-16T20:27:28.581" v="44"/>
+          <ac:spMkLst>
+            <pc:docMk/>
+            <pc:sldMk cId="0" sldId="264"/>
+            <ac:spMk id="11" creationId="{00000000-0000-0000-0000-000000000000}"/>
+          </ac:spMkLst>
+        </pc:spChg>
+        <pc:spChg chg="mod">
+          <ac:chgData name="Ryan Elder" userId="0841b4ff-b127-4263-b5e2-9088e1f9be0c" providerId="ADAL" clId="{71BA6446-15FA-43EA-9A1D-A34ACCF7CF48}" dt="2026-04-16T20:27:28.581" v="44"/>
+          <ac:spMkLst>
+            <pc:docMk/>
+            <pc:sldMk cId="0" sldId="264"/>
+            <ac:spMk id="14" creationId="{00000000-0000-0000-0000-000000000000}"/>
+          </ac:spMkLst>
+        </pc:spChg>
+        <pc:spChg chg="mod">
+          <ac:chgData name="Ryan Elder" userId="0841b4ff-b127-4263-b5e2-9088e1f9be0c" providerId="ADAL" clId="{71BA6446-15FA-43EA-9A1D-A34ACCF7CF48}" dt="2026-04-16T20:27:28.581" v="44"/>
+          <ac:spMkLst>
+            <pc:docMk/>
+            <pc:sldMk cId="0" sldId="264"/>
+            <ac:spMk id="18" creationId="{00000000-0000-0000-0000-000000000000}"/>
+          </ac:spMkLst>
+        </pc:spChg>
+        <pc:spChg chg="mod">
+          <ac:chgData name="Ryan Elder" userId="0841b4ff-b127-4263-b5e2-9088e1f9be0c" providerId="ADAL" clId="{71BA6446-15FA-43EA-9A1D-A34ACCF7CF48}" dt="2026-04-16T20:27:28.581" v="44"/>
+          <ac:spMkLst>
+            <pc:docMk/>
+            <pc:sldMk cId="0" sldId="264"/>
+            <ac:spMk id="20" creationId="{00000000-0000-0000-0000-000000000000}"/>
+          </ac:spMkLst>
+        </pc:spChg>
+        <pc:spChg chg="mod">
+          <ac:chgData name="Ryan Elder" userId="0841b4ff-b127-4263-b5e2-9088e1f9be0c" providerId="ADAL" clId="{71BA6446-15FA-43EA-9A1D-A34ACCF7CF48}" dt="2026-04-16T20:27:28.581" v="44"/>
+          <ac:spMkLst>
+            <pc:docMk/>
+            <pc:sldMk cId="0" sldId="264"/>
+            <ac:spMk id="36" creationId="{00000000-0000-0000-0000-000000000000}"/>
+          </ac:spMkLst>
+        </pc:spChg>
+        <pc:spChg chg="mod">
+          <ac:chgData name="Ryan Elder" userId="0841b4ff-b127-4263-b5e2-9088e1f9be0c" providerId="ADAL" clId="{71BA6446-15FA-43EA-9A1D-A34ACCF7CF48}" dt="2026-04-16T20:27:28.581" v="44"/>
+          <ac:spMkLst>
+            <pc:docMk/>
+            <pc:sldMk cId="0" sldId="264"/>
+            <ac:spMk id="42" creationId="{00000000-0000-0000-0000-000000000000}"/>
+          </ac:spMkLst>
+        </pc:spChg>
+        <pc:spChg chg="mod">
+          <ac:chgData name="Ryan Elder" userId="0841b4ff-b127-4263-b5e2-9088e1f9be0c" providerId="ADAL" clId="{71BA6446-15FA-43EA-9A1D-A34ACCF7CF48}" dt="2026-04-16T20:27:28.581" v="44"/>
           <ac:spMkLst>
             <pc:docMk/>
             <pc:sldMk cId="0" sldId="264"/>
@@ -146,6 +954,195 @@
           </ac:spMkLst>
         </pc:spChg>
       </pc:sldChg>
+      <pc:sldChg chg="modSp setBg">
+        <pc:chgData name="Ryan Elder" userId="0841b4ff-b127-4263-b5e2-9088e1f9be0c" providerId="ADAL" clId="{71BA6446-15FA-43EA-9A1D-A34ACCF7CF48}" dt="2026-04-16T20:27:37.958" v="45"/>
+        <pc:sldMkLst>
+          <pc:docMk/>
+          <pc:sldMk cId="0" sldId="265"/>
+        </pc:sldMkLst>
+        <pc:spChg chg="mod">
+          <ac:chgData name="Ryan Elder" userId="0841b4ff-b127-4263-b5e2-9088e1f9be0c" providerId="ADAL" clId="{71BA6446-15FA-43EA-9A1D-A34ACCF7CF48}" dt="2026-04-16T20:27:28.581" v="44"/>
+          <ac:spMkLst>
+            <pc:docMk/>
+            <pc:sldMk cId="0" sldId="265"/>
+            <ac:spMk id="5" creationId="{00000000-0000-0000-0000-000000000000}"/>
+          </ac:spMkLst>
+        </pc:spChg>
+        <pc:spChg chg="mod">
+          <ac:chgData name="Ryan Elder" userId="0841b4ff-b127-4263-b5e2-9088e1f9be0c" providerId="ADAL" clId="{71BA6446-15FA-43EA-9A1D-A34ACCF7CF48}" dt="2026-04-16T20:27:28.581" v="44"/>
+          <ac:spMkLst>
+            <pc:docMk/>
+            <pc:sldMk cId="0" sldId="265"/>
+            <ac:spMk id="6" creationId="{00000000-0000-0000-0000-000000000000}"/>
+          </ac:spMkLst>
+        </pc:spChg>
+        <pc:spChg chg="mod">
+          <ac:chgData name="Ryan Elder" userId="0841b4ff-b127-4263-b5e2-9088e1f9be0c" providerId="ADAL" clId="{71BA6446-15FA-43EA-9A1D-A34ACCF7CF48}" dt="2026-04-16T20:27:28.581" v="44"/>
+          <ac:spMkLst>
+            <pc:docMk/>
+            <pc:sldMk cId="0" sldId="265"/>
+            <ac:spMk id="9" creationId="{00000000-0000-0000-0000-000000000000}"/>
+          </ac:spMkLst>
+        </pc:spChg>
+        <pc:spChg chg="mod">
+          <ac:chgData name="Ryan Elder" userId="0841b4ff-b127-4263-b5e2-9088e1f9be0c" providerId="ADAL" clId="{71BA6446-15FA-43EA-9A1D-A34ACCF7CF48}" dt="2026-04-16T20:27:28.581" v="44"/>
+          <ac:spMkLst>
+            <pc:docMk/>
+            <pc:sldMk cId="0" sldId="265"/>
+            <ac:spMk id="18" creationId="{00000000-0000-0000-0000-000000000000}"/>
+          </ac:spMkLst>
+        </pc:spChg>
+        <pc:spChg chg="mod">
+          <ac:chgData name="Ryan Elder" userId="0841b4ff-b127-4263-b5e2-9088e1f9be0c" providerId="ADAL" clId="{71BA6446-15FA-43EA-9A1D-A34ACCF7CF48}" dt="2026-04-16T20:27:28.581" v="44"/>
+          <ac:spMkLst>
+            <pc:docMk/>
+            <pc:sldMk cId="0" sldId="265"/>
+            <ac:spMk id="19" creationId="{00000000-0000-0000-0000-000000000000}"/>
+          </ac:spMkLst>
+        </pc:spChg>
+        <pc:spChg chg="mod">
+          <ac:chgData name="Ryan Elder" userId="0841b4ff-b127-4263-b5e2-9088e1f9be0c" providerId="ADAL" clId="{71BA6446-15FA-43EA-9A1D-A34ACCF7CF48}" dt="2026-04-16T20:27:28.581" v="44"/>
+          <ac:spMkLst>
+            <pc:docMk/>
+            <pc:sldMk cId="0" sldId="265"/>
+            <ac:spMk id="21" creationId="{00000000-0000-0000-0000-000000000000}"/>
+          </ac:spMkLst>
+        </pc:spChg>
+        <pc:spChg chg="mod">
+          <ac:chgData name="Ryan Elder" userId="0841b4ff-b127-4263-b5e2-9088e1f9be0c" providerId="ADAL" clId="{71BA6446-15FA-43EA-9A1D-A34ACCF7CF48}" dt="2026-04-16T20:27:28.581" v="44"/>
+          <ac:spMkLst>
+            <pc:docMk/>
+            <pc:sldMk cId="0" sldId="265"/>
+            <ac:spMk id="25" creationId="{00000000-0000-0000-0000-000000000000}"/>
+          </ac:spMkLst>
+        </pc:spChg>
+        <pc:spChg chg="mod">
+          <ac:chgData name="Ryan Elder" userId="0841b4ff-b127-4263-b5e2-9088e1f9be0c" providerId="ADAL" clId="{71BA6446-15FA-43EA-9A1D-A34ACCF7CF48}" dt="2026-04-16T20:27:28.581" v="44"/>
+          <ac:spMkLst>
+            <pc:docMk/>
+            <pc:sldMk cId="0" sldId="265"/>
+            <ac:spMk id="26" creationId="{00000000-0000-0000-0000-000000000000}"/>
+          </ac:spMkLst>
+        </pc:spChg>
+        <pc:spChg chg="mod">
+          <ac:chgData name="Ryan Elder" userId="0841b4ff-b127-4263-b5e2-9088e1f9be0c" providerId="ADAL" clId="{71BA6446-15FA-43EA-9A1D-A34ACCF7CF48}" dt="2026-04-16T20:27:28.581" v="44"/>
+          <ac:spMkLst>
+            <pc:docMk/>
+            <pc:sldMk cId="0" sldId="265"/>
+            <ac:spMk id="28" creationId="{00000000-0000-0000-0000-000000000000}"/>
+          </ac:spMkLst>
+        </pc:spChg>
+        <pc:spChg chg="mod">
+          <ac:chgData name="Ryan Elder" userId="0841b4ff-b127-4263-b5e2-9088e1f9be0c" providerId="ADAL" clId="{71BA6446-15FA-43EA-9A1D-A34ACCF7CF48}" dt="2026-04-16T20:27:28.581" v="44"/>
+          <ac:spMkLst>
+            <pc:docMk/>
+            <pc:sldMk cId="0" sldId="265"/>
+            <ac:spMk id="30" creationId="{00000000-0000-0000-0000-000000000000}"/>
+          </ac:spMkLst>
+        </pc:spChg>
+      </pc:sldChg>
+      <pc:sldChg chg="modSp setBg">
+        <pc:chgData name="Ryan Elder" userId="0841b4ff-b127-4263-b5e2-9088e1f9be0c" providerId="ADAL" clId="{71BA6446-15FA-43EA-9A1D-A34ACCF7CF48}" dt="2026-04-16T20:27:37.958" v="45"/>
+        <pc:sldMkLst>
+          <pc:docMk/>
+          <pc:sldMk cId="0" sldId="266"/>
+        </pc:sldMkLst>
+        <pc:spChg chg="mod">
+          <ac:chgData name="Ryan Elder" userId="0841b4ff-b127-4263-b5e2-9088e1f9be0c" providerId="ADAL" clId="{71BA6446-15FA-43EA-9A1D-A34ACCF7CF48}" dt="2026-04-16T20:27:28.581" v="44"/>
+          <ac:spMkLst>
+            <pc:docMk/>
+            <pc:sldMk cId="0" sldId="266"/>
+            <ac:spMk id="2" creationId="{00000000-0000-0000-0000-000000000000}"/>
+          </ac:spMkLst>
+        </pc:spChg>
+        <pc:spChg chg="mod">
+          <ac:chgData name="Ryan Elder" userId="0841b4ff-b127-4263-b5e2-9088e1f9be0c" providerId="ADAL" clId="{71BA6446-15FA-43EA-9A1D-A34ACCF7CF48}" dt="2026-04-16T20:27:28.581" v="44"/>
+          <ac:spMkLst>
+            <pc:docMk/>
+            <pc:sldMk cId="0" sldId="266"/>
+            <ac:spMk id="3" creationId="{00000000-0000-0000-0000-000000000000}"/>
+          </ac:spMkLst>
+        </pc:spChg>
+        <pc:spChg chg="mod">
+          <ac:chgData name="Ryan Elder" userId="0841b4ff-b127-4263-b5e2-9088e1f9be0c" providerId="ADAL" clId="{71BA6446-15FA-43EA-9A1D-A34ACCF7CF48}" dt="2026-04-16T20:27:28.581" v="44"/>
+          <ac:spMkLst>
+            <pc:docMk/>
+            <pc:sldMk cId="0" sldId="266"/>
+            <ac:spMk id="6" creationId="{00000000-0000-0000-0000-000000000000}"/>
+          </ac:spMkLst>
+        </pc:spChg>
+        <pc:spChg chg="mod">
+          <ac:chgData name="Ryan Elder" userId="0841b4ff-b127-4263-b5e2-9088e1f9be0c" providerId="ADAL" clId="{71BA6446-15FA-43EA-9A1D-A34ACCF7CF48}" dt="2026-04-16T20:27:28.581" v="44"/>
+          <ac:spMkLst>
+            <pc:docMk/>
+            <pc:sldMk cId="0" sldId="266"/>
+            <ac:spMk id="8" creationId="{00000000-0000-0000-0000-000000000000}"/>
+          </ac:spMkLst>
+        </pc:spChg>
+        <pc:spChg chg="mod">
+          <ac:chgData name="Ryan Elder" userId="0841b4ff-b127-4263-b5e2-9088e1f9be0c" providerId="ADAL" clId="{71BA6446-15FA-43EA-9A1D-A34ACCF7CF48}" dt="2026-04-16T20:27:28.581" v="44"/>
+          <ac:spMkLst>
+            <pc:docMk/>
+            <pc:sldMk cId="0" sldId="266"/>
+            <ac:spMk id="9" creationId="{00000000-0000-0000-0000-000000000000}"/>
+          </ac:spMkLst>
+        </pc:spChg>
+        <pc:spChg chg="mod">
+          <ac:chgData name="Ryan Elder" userId="0841b4ff-b127-4263-b5e2-9088e1f9be0c" providerId="ADAL" clId="{71BA6446-15FA-43EA-9A1D-A34ACCF7CF48}" dt="2026-04-16T20:27:28.581" v="44"/>
+          <ac:spMkLst>
+            <pc:docMk/>
+            <pc:sldMk cId="0" sldId="266"/>
+            <ac:spMk id="12" creationId="{00000000-0000-0000-0000-000000000000}"/>
+          </ac:spMkLst>
+        </pc:spChg>
+        <pc:spChg chg="mod">
+          <ac:chgData name="Ryan Elder" userId="0841b4ff-b127-4263-b5e2-9088e1f9be0c" providerId="ADAL" clId="{71BA6446-15FA-43EA-9A1D-A34ACCF7CF48}" dt="2026-04-16T20:27:28.581" v="44"/>
+          <ac:spMkLst>
+            <pc:docMk/>
+            <pc:sldMk cId="0" sldId="266"/>
+            <ac:spMk id="14" creationId="{00000000-0000-0000-0000-000000000000}"/>
+          </ac:spMkLst>
+        </pc:spChg>
+        <pc:spChg chg="mod">
+          <ac:chgData name="Ryan Elder" userId="0841b4ff-b127-4263-b5e2-9088e1f9be0c" providerId="ADAL" clId="{71BA6446-15FA-43EA-9A1D-A34ACCF7CF48}" dt="2026-04-16T20:27:28.581" v="44"/>
+          <ac:spMkLst>
+            <pc:docMk/>
+            <pc:sldMk cId="0" sldId="266"/>
+            <ac:spMk id="16" creationId="{00000000-0000-0000-0000-000000000000}"/>
+          </ac:spMkLst>
+        </pc:spChg>
+        <pc:spChg chg="mod">
+          <ac:chgData name="Ryan Elder" userId="0841b4ff-b127-4263-b5e2-9088e1f9be0c" providerId="ADAL" clId="{71BA6446-15FA-43EA-9A1D-A34ACCF7CF48}" dt="2026-04-16T20:27:28.581" v="44"/>
+          <ac:spMkLst>
+            <pc:docMk/>
+            <pc:sldMk cId="0" sldId="266"/>
+            <ac:spMk id="18" creationId="{00000000-0000-0000-0000-000000000000}"/>
+          </ac:spMkLst>
+        </pc:spChg>
+        <pc:spChg chg="mod">
+          <ac:chgData name="Ryan Elder" userId="0841b4ff-b127-4263-b5e2-9088e1f9be0c" providerId="ADAL" clId="{71BA6446-15FA-43EA-9A1D-A34ACCF7CF48}" dt="2026-04-16T20:27:28.581" v="44"/>
+          <ac:spMkLst>
+            <pc:docMk/>
+            <pc:sldMk cId="0" sldId="266"/>
+            <ac:spMk id="24" creationId="{00000000-0000-0000-0000-000000000000}"/>
+          </ac:spMkLst>
+        </pc:spChg>
+      </pc:sldChg>
+      <pc:sldMasterChg chg="setBg modSldLayout">
+        <pc:chgData name="Ryan Elder" userId="0841b4ff-b127-4263-b5e2-9088e1f9be0c" providerId="ADAL" clId="{71BA6446-15FA-43EA-9A1D-A34ACCF7CF48}" dt="2026-04-16T20:27:37.958" v="45"/>
+        <pc:sldMasterMkLst>
+          <pc:docMk/>
+          <pc:sldMasterMk cId="0" sldId="2147483648"/>
+        </pc:sldMasterMkLst>
+        <pc:sldLayoutChg chg="setBg">
+          <pc:chgData name="Ryan Elder" userId="0841b4ff-b127-4263-b5e2-9088e1f9be0c" providerId="ADAL" clId="{71BA6446-15FA-43EA-9A1D-A34ACCF7CF48}" dt="2026-04-16T20:27:37.958" v="45"/>
+          <pc:sldLayoutMkLst>
+            <pc:docMk/>
+            <pc:sldMasterMk cId="0" sldId="2147483648"/>
+            <pc:sldLayoutMk cId="0" sldId="2147483649"/>
+          </pc:sldLayoutMkLst>
+        </pc:sldLayoutChg>
+      </pc:sldMasterChg>
     </pc:docChg>
   </pc:docChgLst>
 </pc:chgInfo>
@@ -1203,11 +2200,6 @@
 <file path=ppt/slideLayouts/slideLayout1.xml><?xml version="1.0" encoding="utf-8"?>
 <p:sldLayout xmlns:a="http://schemas.openxmlformats.org/drawingml/2006/main" xmlns:r="http://schemas.openxmlformats.org/officeDocument/2006/relationships" xmlns:p="http://schemas.openxmlformats.org/presentationml/2006/main" preserve="1">
   <p:cSld name="DEFAULT">
-    <p:bg>
-      <p:bgRef idx="1001">
-        <a:schemeClr val="bg1"/>
-      </p:bgRef>
-    </p:bg>
     <p:spTree>
       <p:nvGrpSpPr>
         <p:cNvPr id="1" name=""/>
@@ -1234,9 +2226,12 @@
 <p:sldMaster xmlns:a="http://schemas.openxmlformats.org/drawingml/2006/main" xmlns:r="http://schemas.openxmlformats.org/officeDocument/2006/relationships" xmlns:p="http://schemas.openxmlformats.org/presentationml/2006/main">
   <p:cSld>
     <p:bg>
-      <p:bgRef idx="1001">
-        <a:schemeClr val="bg1"/>
-      </p:bgRef>
+      <p:bgPr>
+        <a:solidFill>
+          <a:srgbClr val="0D1B2A"/>
+        </a:solidFill>
+        <a:effectLst/>
+      </p:bgPr>
     </p:bg>
     <p:spTree>
       <p:nvGrpSpPr>
@@ -1515,14 +2510,6 @@
 <file path=ppt/slides/slide1.xml><?xml version="1.0" encoding="utf-8"?>
 <p:sld xmlns:a="http://schemas.openxmlformats.org/drawingml/2006/main" xmlns:r="http://schemas.openxmlformats.org/officeDocument/2006/relationships" xmlns:p="http://schemas.openxmlformats.org/presentationml/2006/main">
   <p:cSld name="Slide 1">
-    <p:bg>
-      <p:bgPr>
-        <a:solidFill>
-          <a:srgbClr val="0D1B2A"/>
-        </a:solidFill>
-        <a:effectLst/>
-      </p:bgPr>
-    </p:bg>
     <p:spTree>
       <p:nvGrpSpPr>
         <p:cNvPr id="1" name=""/>
@@ -1585,9 +2572,7 @@
           <a:bodyPr wrap="square" lIns="0" tIns="0" rIns="0" bIns="0" rtlCol="0" anchor="ctr"/>
           <a:lstStyle/>
           <a:p>
-            <a:pPr marL="0" indent="0" algn="ctr">
-              <a:buNone/>
-            </a:pPr>
+            <a:pPr algn="ctr"/>
             <a:r>
               <a:rPr lang="en-US" sz="1400" b="1" dirty="0">
                 <a:solidFill>
@@ -1621,9 +2606,6 @@
           <a:bodyPr wrap="square" lIns="0" tIns="0" rIns="0" bIns="0" rtlCol="0" anchor="ctr"/>
           <a:lstStyle/>
           <a:p>
-            <a:pPr marL="0" indent="0">
-              <a:buNone/>
-            </a:pPr>
             <a:r>
               <a:rPr lang="en-US" sz="1400" b="1" dirty="0">
                 <a:solidFill>
@@ -1657,9 +2639,6 @@
           <a:bodyPr wrap="square" lIns="0" tIns="0" rIns="0" bIns="0" rtlCol="0" anchor="ctr"/>
           <a:lstStyle/>
           <a:p>
-            <a:pPr marL="0" indent="0" algn="l">
-              <a:buNone/>
-            </a:pPr>
             <a:r>
               <a:rPr lang="en-US" sz="3800" b="1" dirty="0">
                 <a:solidFill>
@@ -1671,9 +2650,6 @@
             <a:endParaRPr lang="en-US" sz="3800" dirty="0"/>
           </a:p>
           <a:p>
-            <a:pPr marL="0" indent="0" algn="l">
-              <a:buNone/>
-            </a:pPr>
             <a:r>
               <a:rPr lang="en-US" sz="3800" b="1" dirty="0">
                 <a:solidFill>
@@ -1707,9 +2683,6 @@
           <a:bodyPr wrap="square" lIns="0" tIns="0" rIns="0" bIns="0" rtlCol="0" anchor="ctr"/>
           <a:lstStyle/>
           <a:p>
-            <a:pPr marL="0" indent="0" algn="l">
-              <a:buNone/>
-            </a:pPr>
             <a:r>
               <a:rPr lang="en-US" sz="1300" dirty="0">
                 <a:solidFill>
@@ -1743,9 +2716,6 @@
           <a:bodyPr wrap="square" lIns="0" tIns="0" rIns="0" bIns="0" rtlCol="0" anchor="ctr"/>
           <a:lstStyle/>
           <a:p>
-            <a:pPr marL="0" indent="0" algn="l">
-              <a:buNone/>
-            </a:pPr>
             <a:r>
               <a:rPr lang="en-US" sz="1200" dirty="0">
                 <a:solidFill>
@@ -1806,9 +2776,6 @@
           <a:bodyPr wrap="square" lIns="0" tIns="0" rIns="0" bIns="0" rtlCol="0" anchor="ctr"/>
           <a:lstStyle/>
           <a:p>
-            <a:pPr marL="0" indent="0" algn="l">
-              <a:buNone/>
-            </a:pPr>
             <a:r>
               <a:rPr lang="en-US" sz="1000" dirty="0">
                 <a:solidFill>
@@ -1869,9 +2836,7 @@
           <a:bodyPr wrap="square" lIns="0" tIns="0" rIns="0" bIns="0" rtlCol="0" anchor="ctr"/>
           <a:lstStyle/>
           <a:p>
-            <a:pPr marL="0" indent="0" algn="ctr">
-              <a:buNone/>
-            </a:pPr>
+            <a:pPr algn="ctr"/>
             <a:r>
               <a:rPr lang="en-US" sz="1000" b="1" dirty="0">
                 <a:solidFill>
@@ -1905,9 +2870,7 @@
           <a:bodyPr wrap="square" lIns="0" tIns="0" rIns="0" bIns="0" rtlCol="0" anchor="ctr"/>
           <a:lstStyle/>
           <a:p>
-            <a:pPr marL="0" indent="0" algn="ctr">
-              <a:buNone/>
-            </a:pPr>
+            <a:pPr algn="ctr"/>
             <a:r>
               <a:rPr lang="en-US" sz="850" dirty="0">
                 <a:solidFill>
@@ -1968,9 +2931,7 @@
           <a:bodyPr wrap="square" lIns="0" tIns="0" rIns="0" bIns="0" rtlCol="0" anchor="ctr"/>
           <a:lstStyle/>
           <a:p>
-            <a:pPr marL="0" indent="0" algn="ctr">
-              <a:buNone/>
-            </a:pPr>
+            <a:pPr algn="ctr"/>
             <a:r>
               <a:rPr lang="en-US" sz="1000" b="1" dirty="0">
                 <a:solidFill>
@@ -2004,9 +2965,7 @@
           <a:bodyPr wrap="square" lIns="0" tIns="0" rIns="0" bIns="0" rtlCol="0" anchor="ctr"/>
           <a:lstStyle/>
           <a:p>
-            <a:pPr marL="0" indent="0" algn="ctr">
-              <a:buNone/>
-            </a:pPr>
+            <a:pPr algn="ctr"/>
             <a:r>
               <a:rPr lang="en-US" sz="850" dirty="0">
                 <a:solidFill>
@@ -2067,9 +3026,7 @@
           <a:bodyPr wrap="square" lIns="0" tIns="0" rIns="0" bIns="0" rtlCol="0" anchor="ctr"/>
           <a:lstStyle/>
           <a:p>
-            <a:pPr marL="0" indent="0" algn="ctr">
-              <a:buNone/>
-            </a:pPr>
+            <a:pPr algn="ctr"/>
             <a:r>
               <a:rPr lang="en-US" sz="1000" b="1" dirty="0">
                 <a:solidFill>
@@ -2103,9 +3060,7 @@
           <a:bodyPr wrap="square" lIns="0" tIns="0" rIns="0" bIns="0" rtlCol="0" anchor="ctr"/>
           <a:lstStyle/>
           <a:p>
-            <a:pPr marL="0" indent="0" algn="ctr">
-              <a:buNone/>
-            </a:pPr>
+            <a:pPr algn="ctr"/>
             <a:r>
               <a:rPr lang="en-US" sz="850" dirty="0">
                 <a:solidFill>
@@ -2129,14 +3084,6 @@
 <file path=ppt/slides/slide10.xml><?xml version="1.0" encoding="utf-8"?>
 <p:sld xmlns:a="http://schemas.openxmlformats.org/drawingml/2006/main" xmlns:r="http://schemas.openxmlformats.org/officeDocument/2006/relationships" xmlns:p="http://schemas.openxmlformats.org/presentationml/2006/main">
   <p:cSld name="Slide 10">
-    <p:bg>
-      <p:bgPr>
-        <a:solidFill>
-          <a:srgbClr val="0D1B2A"/>
-        </a:solidFill>
-        <a:effectLst/>
-      </p:bgPr>
-    </p:bg>
     <p:spTree>
       <p:nvGrpSpPr>
         <p:cNvPr id="1" name=""/>
@@ -2199,9 +3146,6 @@
           <a:bodyPr wrap="square" lIns="0" tIns="0" rIns="0" bIns="0" rtlCol="0" anchor="ctr"/>
           <a:lstStyle/>
           <a:p>
-            <a:pPr marL="0" indent="0">
-              <a:buNone/>
-            </a:pPr>
             <a:r>
               <a:rPr lang="en-US" sz="1100" b="1" kern="0" spc="300" dirty="0">
                 <a:solidFill>
@@ -2235,9 +3179,6 @@
           <a:bodyPr wrap="square" lIns="0" tIns="0" rIns="0" bIns="0" rtlCol="0" anchor="ctr"/>
           <a:lstStyle/>
           <a:p>
-            <a:pPr marL="0" indent="0">
-              <a:buNone/>
-            </a:pPr>
             <a:r>
               <a:rPr lang="en-US" sz="2000" b="1" dirty="0">
                 <a:solidFill>
@@ -2310,9 +3251,7 @@
           <a:bodyPr wrap="square" lIns="0" tIns="0" rIns="0" bIns="0" rtlCol="0" anchor="ctr"/>
           <a:lstStyle/>
           <a:p>
-            <a:pPr marL="0" indent="0" algn="ctr">
-              <a:buNone/>
-            </a:pPr>
+            <a:pPr algn="ctr"/>
             <a:r>
               <a:rPr lang="en-US" sz="2200" b="1" dirty="0">
                 <a:solidFill>
@@ -2397,9 +3336,6 @@
           <a:bodyPr wrap="square" lIns="0" tIns="0" rIns="0" bIns="0" rtlCol="0" anchor="ctr"/>
           <a:lstStyle/>
           <a:p>
-            <a:pPr marL="0" indent="0">
-              <a:buNone/>
-            </a:pPr>
             <a:r>
               <a:rPr lang="en-US" sz="1200" b="1" dirty="0">
                 <a:solidFill>
@@ -2433,9 +3369,6 @@
           <a:bodyPr wrap="square" lIns="0" tIns="0" rIns="0" bIns="0" rtlCol="0" anchor="ctr"/>
           <a:lstStyle/>
           <a:p>
-            <a:pPr marL="0" indent="0">
-              <a:buNone/>
-            </a:pPr>
             <a:r>
               <a:rPr lang="en-US" sz="1000" dirty="0">
                 <a:solidFill>
@@ -2535,9 +3468,7 @@
           <a:bodyPr wrap="square" lIns="0" tIns="0" rIns="0" bIns="0" rtlCol="0" anchor="ctr"/>
           <a:lstStyle/>
           <a:p>
-            <a:pPr marL="0" indent="0" algn="ctr">
-              <a:buNone/>
-            </a:pPr>
+            <a:pPr algn="ctr"/>
             <a:r>
               <a:rPr lang="en-US" sz="2200" b="1" dirty="0">
                 <a:solidFill>
@@ -2622,9 +3553,6 @@
           <a:bodyPr wrap="square" lIns="0" tIns="0" rIns="0" bIns="0" rtlCol="0" anchor="ctr"/>
           <a:lstStyle/>
           <a:p>
-            <a:pPr marL="0" indent="0">
-              <a:buNone/>
-            </a:pPr>
             <a:r>
               <a:rPr lang="en-US" sz="1200" b="1" dirty="0">
                 <a:solidFill>
@@ -2658,9 +3586,6 @@
           <a:bodyPr wrap="square" lIns="0" tIns="0" rIns="0" bIns="0" rtlCol="0" anchor="ctr"/>
           <a:lstStyle/>
           <a:p>
-            <a:pPr marL="0" indent="0">
-              <a:buNone/>
-            </a:pPr>
             <a:r>
               <a:rPr lang="en-US" sz="1000" dirty="0">
                 <a:solidFill>
@@ -2760,9 +3685,7 @@
           <a:bodyPr wrap="square" lIns="0" tIns="0" rIns="0" bIns="0" rtlCol="0" anchor="ctr"/>
           <a:lstStyle/>
           <a:p>
-            <a:pPr marL="0" indent="0" algn="ctr">
-              <a:buNone/>
-            </a:pPr>
+            <a:pPr algn="ctr"/>
             <a:r>
               <a:rPr lang="en-US" sz="2200" b="1" dirty="0">
                 <a:solidFill>
@@ -2847,9 +3770,6 @@
           <a:bodyPr wrap="square" lIns="0" tIns="0" rIns="0" bIns="0" rtlCol="0" anchor="ctr"/>
           <a:lstStyle/>
           <a:p>
-            <a:pPr marL="0" indent="0">
-              <a:buNone/>
-            </a:pPr>
             <a:r>
               <a:rPr lang="en-US" sz="1200" b="1" dirty="0">
                 <a:solidFill>
@@ -2883,9 +3803,6 @@
           <a:bodyPr wrap="square" lIns="0" tIns="0" rIns="0" bIns="0" rtlCol="0" anchor="ctr"/>
           <a:lstStyle/>
           <a:p>
-            <a:pPr marL="0" indent="0">
-              <a:buNone/>
-            </a:pPr>
             <a:r>
               <a:rPr lang="en-US" sz="1000" dirty="0">
                 <a:solidFill>
@@ -2985,9 +3902,7 @@
           <a:bodyPr wrap="square" lIns="0" tIns="0" rIns="0" bIns="0" rtlCol="0" anchor="ctr"/>
           <a:lstStyle/>
           <a:p>
-            <a:pPr marL="0" indent="0" algn="ctr">
-              <a:buNone/>
-            </a:pPr>
+            <a:pPr algn="ctr"/>
             <a:r>
               <a:rPr lang="en-US" sz="2200" b="1" dirty="0">
                 <a:solidFill>
@@ -3072,9 +3987,6 @@
           <a:bodyPr wrap="square" lIns="0" tIns="0" rIns="0" bIns="0" rtlCol="0" anchor="ctr"/>
           <a:lstStyle/>
           <a:p>
-            <a:pPr marL="0" indent="0">
-              <a:buNone/>
-            </a:pPr>
             <a:r>
               <a:rPr lang="en-US" sz="1200" b="1" dirty="0">
                 <a:solidFill>
@@ -3108,9 +4020,6 @@
           <a:bodyPr wrap="square" lIns="0" tIns="0" rIns="0" bIns="0" rtlCol="0" anchor="ctr"/>
           <a:lstStyle/>
           <a:p>
-            <a:pPr marL="0" indent="0">
-              <a:buNone/>
-            </a:pPr>
             <a:r>
               <a:rPr lang="en-US" sz="1000" dirty="0">
                 <a:solidFill>
@@ -3161,14 +4070,6 @@
 <file path=ppt/slides/slide11.xml><?xml version="1.0" encoding="utf-8"?>
 <p:sld xmlns:a="http://schemas.openxmlformats.org/drawingml/2006/main" xmlns:r="http://schemas.openxmlformats.org/officeDocument/2006/relationships" xmlns:p="http://schemas.openxmlformats.org/presentationml/2006/main">
   <p:cSld name="Slide 11">
-    <p:bg>
-      <p:bgPr>
-        <a:solidFill>
-          <a:srgbClr val="0D1B2A"/>
-        </a:solidFill>
-        <a:effectLst/>
-      </p:bgPr>
-    </p:bg>
     <p:spTree>
       <p:nvGrpSpPr>
         <p:cNvPr id="1" name=""/>
@@ -3231,9 +4132,7 @@
           <a:bodyPr wrap="square" lIns="0" tIns="0" rIns="0" bIns="0" rtlCol="0" anchor="ctr"/>
           <a:lstStyle/>
           <a:p>
-            <a:pPr marL="0" indent="0" algn="ctr">
-              <a:buNone/>
-            </a:pPr>
+            <a:pPr algn="ctr"/>
             <a:r>
               <a:rPr lang="en-US" sz="1400" b="1" dirty="0">
                 <a:solidFill>
@@ -3267,9 +4166,6 @@
           <a:bodyPr wrap="square" lIns="0" tIns="0" rIns="0" bIns="0" rtlCol="0" anchor="ctr"/>
           <a:lstStyle/>
           <a:p>
-            <a:pPr marL="0" indent="0">
-              <a:buNone/>
-            </a:pPr>
             <a:r>
               <a:rPr lang="en-US" sz="1400" b="1" dirty="0">
                 <a:solidFill>
@@ -3303,9 +4199,6 @@
           <a:bodyPr wrap="square" lIns="0" tIns="0" rIns="0" bIns="0" rtlCol="0" anchor="ctr"/>
           <a:lstStyle/>
           <a:p>
-            <a:pPr marL="0" indent="0">
-              <a:buNone/>
-            </a:pPr>
             <a:r>
               <a:rPr lang="en-US" sz="2600" b="1" dirty="0">
                 <a:solidFill>
@@ -3317,9 +4210,6 @@
             <a:endParaRPr lang="en-US" sz="2600" dirty="0"/>
           </a:p>
           <a:p>
-            <a:pPr marL="0" indent="0">
-              <a:buNone/>
-            </a:pPr>
             <a:r>
               <a:rPr lang="en-US" sz="2600" b="1" dirty="0">
                 <a:solidFill>
@@ -3331,9 +4221,6 @@
             <a:endParaRPr lang="en-US" sz="2600" dirty="0"/>
           </a:p>
           <a:p>
-            <a:pPr marL="0" indent="0">
-              <a:buNone/>
-            </a:pPr>
             <a:r>
               <a:rPr lang="en-US" sz="2600" b="1" dirty="0">
                 <a:solidFill>
@@ -3367,9 +4254,6 @@
           <a:bodyPr wrap="square" lIns="0" tIns="0" rIns="0" bIns="0" rtlCol="0" anchor="ctr"/>
           <a:lstStyle/>
           <a:p>
-            <a:pPr marL="0" indent="0">
-              <a:buNone/>
-            </a:pPr>
             <a:r>
               <a:rPr lang="en-US" sz="1100" dirty="0">
                 <a:solidFill>
@@ -3430,9 +4314,6 @@
           <a:bodyPr wrap="square" lIns="0" tIns="0" rIns="0" bIns="0" rtlCol="0" anchor="ctr"/>
           <a:lstStyle/>
           <a:p>
-            <a:pPr marL="0" indent="0">
-              <a:buNone/>
-            </a:pPr>
             <a:r>
               <a:rPr lang="en-US" sz="1100" dirty="0">
                 <a:solidFill>
@@ -3466,9 +4347,6 @@
           <a:bodyPr wrap="square" lIns="0" tIns="0" rIns="0" bIns="0" rtlCol="0" anchor="ctr"/>
           <a:lstStyle/>
           <a:p>
-            <a:pPr marL="0" indent="0">
-              <a:buNone/>
-            </a:pPr>
             <a:r>
               <a:rPr lang="en-US" sz="1100" dirty="0">
                 <a:solidFill>
@@ -3502,9 +4380,6 @@
           <a:bodyPr wrap="square" lIns="0" tIns="0" rIns="0" bIns="0" rtlCol="0" anchor="ctr"/>
           <a:lstStyle/>
           <a:p>
-            <a:pPr marL="0" indent="0">
-              <a:buNone/>
-            </a:pPr>
             <a:r>
               <a:rPr lang="en-US" sz="1100" dirty="0">
                 <a:solidFill>
@@ -3577,9 +4452,6 @@
           <a:bodyPr wrap="square" lIns="0" tIns="0" rIns="0" bIns="0" rtlCol="0" anchor="ctr"/>
           <a:lstStyle/>
           <a:p>
-            <a:pPr marL="0" indent="0">
-              <a:buNone/>
-            </a:pPr>
             <a:r>
               <a:rPr lang="en-US" sz="1100" b="1" dirty="0">
                 <a:solidFill>
@@ -3637,9 +4509,6 @@
           <a:bodyPr wrap="square" lIns="0" tIns="0" rIns="0" bIns="0" rtlCol="0" anchor="ctr"/>
           <a:lstStyle/>
           <a:p>
-            <a:pPr marL="0" indent="0">
-              <a:buNone/>
-            </a:pPr>
             <a:r>
               <a:rPr lang="en-US" sz="1100" dirty="0">
                 <a:solidFill>
@@ -3697,9 +4566,6 @@
           <a:bodyPr wrap="square" lIns="0" tIns="0" rIns="0" bIns="0" rtlCol="0" anchor="ctr"/>
           <a:lstStyle/>
           <a:p>
-            <a:pPr marL="0" indent="0">
-              <a:buNone/>
-            </a:pPr>
             <a:r>
               <a:rPr lang="en-US" sz="1100" dirty="0">
                 <a:solidFill>
@@ -3757,9 +4623,6 @@
           <a:bodyPr wrap="square" lIns="0" tIns="0" rIns="0" bIns="0" rtlCol="0" anchor="ctr"/>
           <a:lstStyle/>
           <a:p>
-            <a:pPr marL="0" indent="0">
-              <a:buNone/>
-            </a:pPr>
             <a:r>
               <a:rPr lang="en-US" sz="1100" dirty="0">
                 <a:solidFill>
@@ -3817,9 +4680,6 @@
           <a:bodyPr wrap="square" lIns="0" tIns="0" rIns="0" bIns="0" rtlCol="0" anchor="ctr"/>
           <a:lstStyle/>
           <a:p>
-            <a:pPr marL="0" indent="0">
-              <a:buNone/>
-            </a:pPr>
             <a:r>
               <a:rPr lang="en-US" sz="1100" dirty="0">
                 <a:solidFill>
@@ -3877,9 +4737,6 @@
           <a:bodyPr wrap="square" lIns="0" tIns="0" rIns="0" bIns="0" rtlCol="0" anchor="ctr"/>
           <a:lstStyle/>
           <a:p>
-            <a:pPr marL="0" indent="0">
-              <a:buNone/>
-            </a:pPr>
             <a:r>
               <a:rPr lang="en-US" sz="1100" dirty="0">
                 <a:solidFill>
@@ -3937,9 +4794,6 @@
           <a:bodyPr wrap="square" lIns="0" tIns="0" rIns="0" bIns="0" rtlCol="0" anchor="ctr"/>
           <a:lstStyle/>
           <a:p>
-            <a:pPr marL="0" indent="0">
-              <a:buNone/>
-            </a:pPr>
             <a:r>
               <a:rPr lang="en-US" sz="1100" dirty="0">
                 <a:solidFill>
@@ -3963,14 +4817,6 @@
 <file path=ppt/slides/slide2.xml><?xml version="1.0" encoding="utf-8"?>
 <p:sld xmlns:a="http://schemas.openxmlformats.org/drawingml/2006/main" xmlns:r="http://schemas.openxmlformats.org/officeDocument/2006/relationships" xmlns:p="http://schemas.openxmlformats.org/presentationml/2006/main">
   <p:cSld name="Slide 2">
-    <p:bg>
-      <p:bgPr>
-        <a:solidFill>
-          <a:srgbClr val="0D1B2A"/>
-        </a:solidFill>
-        <a:effectLst/>
-      </p:bgPr>
-    </p:bg>
     <p:spTree>
       <p:nvGrpSpPr>
         <p:cNvPr id="1" name=""/>
@@ -4033,9 +4879,6 @@
           <a:bodyPr wrap="square" lIns="0" tIns="0" rIns="0" bIns="0" rtlCol="0" anchor="ctr"/>
           <a:lstStyle/>
           <a:p>
-            <a:pPr marL="0" indent="0">
-              <a:buNone/>
-            </a:pPr>
             <a:r>
               <a:rPr lang="en-US" sz="1100" b="1" kern="0" spc="300" dirty="0">
                 <a:solidFill>
@@ -4069,9 +4912,6 @@
           <a:bodyPr wrap="square" lIns="0" tIns="0" rIns="0" bIns="0" rtlCol="0" anchor="ctr"/>
           <a:lstStyle/>
           <a:p>
-            <a:pPr marL="0" indent="0">
-              <a:buNone/>
-            </a:pPr>
             <a:r>
               <a:rPr lang="en-US" sz="2200" b="1" dirty="0">
                 <a:solidFill>
@@ -4083,9 +4923,6 @@
             <a:endParaRPr lang="en-US" sz="2200" dirty="0"/>
           </a:p>
           <a:p>
-            <a:pPr marL="0" indent="0">
-              <a:buNone/>
-            </a:pPr>
             <a:r>
               <a:rPr lang="en-US" sz="2200" b="1" dirty="0">
                 <a:solidFill>
@@ -4209,9 +5046,6 @@
           <a:bodyPr wrap="square" lIns="0" tIns="0" rIns="0" bIns="0" rtlCol="0" anchor="ctr"/>
           <a:lstStyle/>
           <a:p>
-            <a:pPr marL="0" indent="0">
-              <a:buNone/>
-            </a:pPr>
             <a:r>
               <a:rPr lang="en-US" sz="1200" b="1" dirty="0">
                 <a:solidFill>
@@ -4245,9 +5079,6 @@
           <a:bodyPr wrap="square" lIns="0" tIns="0" rIns="0" bIns="0" rtlCol="0" anchor="t"/>
           <a:lstStyle/>
           <a:p>
-            <a:pPr marL="0" indent="0">
-              <a:buNone/>
-            </a:pPr>
             <a:r>
               <a:rPr lang="en-US" sz="1100" dirty="0">
                 <a:solidFill>
@@ -4371,9 +5202,6 @@
           <a:bodyPr wrap="square" lIns="0" tIns="0" rIns="0" bIns="0" rtlCol="0" anchor="ctr"/>
           <a:lstStyle/>
           <a:p>
-            <a:pPr marL="0" indent="0">
-              <a:buNone/>
-            </a:pPr>
             <a:r>
               <a:rPr lang="en-US" sz="1200" b="1" dirty="0">
                 <a:solidFill>
@@ -4407,9 +5235,6 @@
           <a:bodyPr wrap="square" lIns="0" tIns="0" rIns="0" bIns="0" rtlCol="0" anchor="t"/>
           <a:lstStyle/>
           <a:p>
-            <a:pPr marL="0" indent="0">
-              <a:buNone/>
-            </a:pPr>
             <a:r>
               <a:rPr lang="en-US" sz="1100" dirty="0">
                 <a:solidFill>
@@ -4533,9 +5358,6 @@
           <a:bodyPr wrap="square" lIns="0" tIns="0" rIns="0" bIns="0" rtlCol="0" anchor="ctr"/>
           <a:lstStyle/>
           <a:p>
-            <a:pPr marL="0" indent="0">
-              <a:buNone/>
-            </a:pPr>
             <a:r>
               <a:rPr lang="en-US" sz="1200" b="1" dirty="0">
                 <a:solidFill>
@@ -4569,9 +5391,6 @@
           <a:bodyPr wrap="square" lIns="0" tIns="0" rIns="0" bIns="0" rtlCol="0" anchor="t"/>
           <a:lstStyle/>
           <a:p>
-            <a:pPr marL="0" indent="0">
-              <a:buNone/>
-            </a:pPr>
             <a:r>
               <a:rPr lang="en-US" sz="1100" dirty="0">
                 <a:solidFill>
@@ -4637,9 +5456,7 @@
           <a:bodyPr wrap="square" lIns="0" tIns="0" rIns="0" bIns="0" rtlCol="0" anchor="ctr"/>
           <a:lstStyle/>
           <a:p>
-            <a:pPr marL="0" indent="0" algn="ctr">
-              <a:buNone/>
-            </a:pPr>
+            <a:pPr algn="ctr"/>
             <a:r>
               <a:rPr lang="en-US" sz="1100" i="1" dirty="0">
                 <a:solidFill>
@@ -4663,14 +5480,6 @@
 <file path=ppt/slides/slide3.xml><?xml version="1.0" encoding="utf-8"?>
 <p:sld xmlns:a="http://schemas.openxmlformats.org/drawingml/2006/main" xmlns:r="http://schemas.openxmlformats.org/officeDocument/2006/relationships" xmlns:p="http://schemas.openxmlformats.org/presentationml/2006/main">
   <p:cSld name="Slide 3">
-    <p:bg>
-      <p:bgPr>
-        <a:solidFill>
-          <a:srgbClr val="0D1B2A"/>
-        </a:solidFill>
-        <a:effectLst/>
-      </p:bgPr>
-    </p:bg>
     <p:spTree>
       <p:nvGrpSpPr>
         <p:cNvPr id="1" name=""/>
@@ -4733,9 +5542,6 @@
           <a:bodyPr wrap="square" lIns="0" tIns="0" rIns="0" bIns="0" rtlCol="0" anchor="ctr"/>
           <a:lstStyle/>
           <a:p>
-            <a:pPr marL="0" indent="0">
-              <a:buNone/>
-            </a:pPr>
             <a:r>
               <a:rPr lang="en-US" sz="1100" b="1" kern="0" spc="300" dirty="0">
                 <a:solidFill>
@@ -4769,9 +5575,6 @@
           <a:bodyPr wrap="square" lIns="0" tIns="0" rIns="0" bIns="0" rtlCol="0" anchor="ctr"/>
           <a:lstStyle/>
           <a:p>
-            <a:pPr marL="0" indent="0">
-              <a:buNone/>
-            </a:pPr>
             <a:r>
               <a:rPr lang="en-US" sz="2400" b="1" dirty="0">
                 <a:solidFill>
@@ -4783,9 +5586,6 @@
             <a:endParaRPr lang="en-US" sz="2400" dirty="0"/>
           </a:p>
           <a:p>
-            <a:pPr marL="0" indent="0">
-              <a:buNone/>
-            </a:pPr>
             <a:r>
               <a:rPr lang="en-US" sz="2400" b="1" dirty="0">
                 <a:solidFill>
@@ -4885,9 +5685,7 @@
           <a:bodyPr wrap="square" lIns="0" tIns="0" rIns="0" bIns="0" rtlCol="0" anchor="ctr"/>
           <a:lstStyle/>
           <a:p>
-            <a:pPr marL="0" indent="0" algn="ctr">
-              <a:buNone/>
-            </a:pPr>
+            <a:pPr algn="ctr"/>
             <a:r>
               <a:rPr lang="en-US" sz="1100" b="1" dirty="0">
                 <a:solidFill>
@@ -4921,9 +5719,6 @@
           <a:bodyPr wrap="square" lIns="0" tIns="0" rIns="0" bIns="0" rtlCol="0" anchor="ctr"/>
           <a:lstStyle/>
           <a:p>
-            <a:pPr marL="0" indent="0">
-              <a:buNone/>
-            </a:pPr>
             <a:r>
               <a:rPr lang="en-US" sz="1000" dirty="0">
                 <a:solidFill>
@@ -4957,9 +5752,7 @@
           <a:bodyPr wrap="square" lIns="0" tIns="0" rIns="0" bIns="0" rtlCol="0" anchor="ctr"/>
           <a:lstStyle/>
           <a:p>
-            <a:pPr marL="0" indent="0" algn="ctr">
-              <a:buNone/>
-            </a:pPr>
+            <a:pPr algn="ctr"/>
             <a:r>
               <a:rPr lang="en-US" sz="8800" b="1" dirty="0">
                 <a:solidFill>
@@ -5047,9 +5840,6 @@
           <a:bodyPr wrap="square" lIns="0" tIns="0" rIns="0" bIns="0" rtlCol="0" anchor="ctr"/>
           <a:lstStyle/>
           <a:p>
-            <a:pPr marL="0" indent="0">
-              <a:buNone/>
-            </a:pPr>
             <a:r>
               <a:rPr lang="en-US" sz="900" dirty="0">
                 <a:solidFill>
@@ -5083,9 +5873,6 @@
           <a:bodyPr wrap="square" lIns="0" tIns="0" rIns="0" bIns="0" rtlCol="0" anchor="ctr"/>
           <a:lstStyle/>
           <a:p>
-            <a:pPr marL="0" indent="0">
-              <a:buNone/>
-            </a:pPr>
             <a:r>
               <a:rPr lang="en-US" sz="900" dirty="0">
                 <a:solidFill>
@@ -5119,9 +5906,7 @@
           <a:bodyPr wrap="square" lIns="0" tIns="0" rIns="0" bIns="0" rtlCol="0" anchor="ctr"/>
           <a:lstStyle/>
           <a:p>
-            <a:pPr marL="0" indent="0" algn="ctr">
-              <a:buNone/>
-            </a:pPr>
+            <a:pPr algn="ctr"/>
             <a:r>
               <a:rPr lang="en-US" sz="1000" dirty="0">
                 <a:solidFill>
@@ -5133,16 +5918,14 @@
             <a:endParaRPr lang="en-US" sz="1000" dirty="0"/>
           </a:p>
           <a:p>
-            <a:pPr marL="0" indent="0" algn="ctr">
-              <a:buNone/>
-            </a:pPr>
+            <a:pPr algn="ctr"/>
             <a:r>
               <a:rPr lang="en-US" sz="1000" dirty="0">
                 <a:solidFill>
                   <a:srgbClr val="B8CCE0"/>
                 </a:solidFill>
               </a:rPr>
-              <a:t>ABC General Contractors · Your Area</a:t>
+              <a:t>ABC Subcontractors · Overland Park, KS</a:t>
             </a:r>
             <a:endParaRPr lang="en-US" sz="1000" dirty="0"/>
           </a:p>
@@ -5169,9 +5952,6 @@
           <a:bodyPr wrap="square" lIns="0" tIns="0" rIns="0" bIns="0" rtlCol="0" anchor="ctr"/>
           <a:lstStyle/>
           <a:p>
-            <a:pPr marL="0" indent="0">
-              <a:buNone/>
-            </a:pPr>
             <a:r>
               <a:rPr lang="en-US" sz="1300" b="1" dirty="0">
                 <a:solidFill>
@@ -5271,9 +6051,6 @@
           <a:bodyPr wrap="square" lIns="0" tIns="0" rIns="0" bIns="0" rtlCol="0" anchor="ctr"/>
           <a:lstStyle/>
           <a:p>
-            <a:pPr marL="0" indent="0">
-              <a:buNone/>
-            </a:pPr>
             <a:r>
               <a:rPr lang="en-US" sz="1050" b="1" dirty="0">
                 <a:solidFill>
@@ -5307,9 +6084,6 @@
           <a:bodyPr wrap="square" lIns="0" tIns="0" rIns="0" bIns="0" rtlCol="0" anchor="ctr"/>
           <a:lstStyle/>
           <a:p>
-            <a:pPr marL="0" indent="0">
-              <a:buNone/>
-            </a:pPr>
             <a:r>
               <a:rPr lang="en-US" sz="850" dirty="0">
                 <a:solidFill>
@@ -5343,9 +6117,7 @@
           <a:bodyPr wrap="square" lIns="0" tIns="0" rIns="0" bIns="0" rtlCol="0" anchor="ctr"/>
           <a:lstStyle/>
           <a:p>
-            <a:pPr marL="0" indent="0" algn="ctr">
-              <a:buNone/>
-            </a:pPr>
+            <a:pPr algn="ctr"/>
             <a:r>
               <a:rPr lang="en-US" sz="1000" b="1" dirty="0">
                 <a:solidFill>
@@ -5433,9 +6205,6 @@
           <a:bodyPr wrap="square" lIns="0" tIns="0" rIns="0" bIns="0" rtlCol="0" anchor="ctr"/>
           <a:lstStyle/>
           <a:p>
-            <a:pPr marL="0" indent="0">
-              <a:buNone/>
-            </a:pPr>
             <a:r>
               <a:rPr lang="en-US" sz="1000" b="1" dirty="0">
                 <a:solidFill>
@@ -5535,9 +6304,6 @@
           <a:bodyPr wrap="square" lIns="0" tIns="0" rIns="0" bIns="0" rtlCol="0" anchor="ctr"/>
           <a:lstStyle/>
           <a:p>
-            <a:pPr marL="0" indent="0">
-              <a:buNone/>
-            </a:pPr>
             <a:r>
               <a:rPr lang="en-US" sz="1050" b="1" dirty="0">
                 <a:solidFill>
@@ -5571,9 +6337,6 @@
           <a:bodyPr wrap="square" lIns="0" tIns="0" rIns="0" bIns="0" rtlCol="0" anchor="ctr"/>
           <a:lstStyle/>
           <a:p>
-            <a:pPr marL="0" indent="0">
-              <a:buNone/>
-            </a:pPr>
             <a:r>
               <a:rPr lang="en-US" sz="850" dirty="0">
                 <a:solidFill>
@@ -5607,9 +6370,7 @@
           <a:bodyPr wrap="square" lIns="0" tIns="0" rIns="0" bIns="0" rtlCol="0" anchor="ctr"/>
           <a:lstStyle/>
           <a:p>
-            <a:pPr marL="0" indent="0" algn="ctr">
-              <a:buNone/>
-            </a:pPr>
+            <a:pPr algn="ctr"/>
             <a:r>
               <a:rPr lang="en-US" sz="1000" b="1" dirty="0">
                 <a:solidFill>
@@ -5697,9 +6458,6 @@
           <a:bodyPr wrap="square" lIns="0" tIns="0" rIns="0" bIns="0" rtlCol="0" anchor="ctr"/>
           <a:lstStyle/>
           <a:p>
-            <a:pPr marL="0" indent="0">
-              <a:buNone/>
-            </a:pPr>
             <a:r>
               <a:rPr lang="en-US" sz="1000" b="1" dirty="0">
                 <a:solidFill>
@@ -5799,9 +6557,6 @@
           <a:bodyPr wrap="square" lIns="0" tIns="0" rIns="0" bIns="0" rtlCol="0" anchor="ctr"/>
           <a:lstStyle/>
           <a:p>
-            <a:pPr marL="0" indent="0">
-              <a:buNone/>
-            </a:pPr>
             <a:r>
               <a:rPr lang="en-US" sz="1050" b="1" dirty="0">
                 <a:solidFill>
@@ -5835,9 +6590,6 @@
           <a:bodyPr wrap="square" lIns="0" tIns="0" rIns="0" bIns="0" rtlCol="0" anchor="ctr"/>
           <a:lstStyle/>
           <a:p>
-            <a:pPr marL="0" indent="0">
-              <a:buNone/>
-            </a:pPr>
             <a:r>
               <a:rPr lang="en-US" sz="850" dirty="0">
                 <a:solidFill>
@@ -5871,9 +6623,7 @@
           <a:bodyPr wrap="square" lIns="0" tIns="0" rIns="0" bIns="0" rtlCol="0" anchor="ctr"/>
           <a:lstStyle/>
           <a:p>
-            <a:pPr marL="0" indent="0" algn="ctr">
-              <a:buNone/>
-            </a:pPr>
+            <a:pPr algn="ctr"/>
             <a:r>
               <a:rPr lang="en-US" sz="1000" b="1" dirty="0">
                 <a:solidFill>
@@ -5961,9 +6711,6 @@
           <a:bodyPr wrap="square" lIns="0" tIns="0" rIns="0" bIns="0" rtlCol="0" anchor="ctr"/>
           <a:lstStyle/>
           <a:p>
-            <a:pPr marL="0" indent="0">
-              <a:buNone/>
-            </a:pPr>
             <a:r>
               <a:rPr lang="en-US" sz="1000" b="1" dirty="0">
                 <a:solidFill>
@@ -6063,9 +6810,6 @@
           <a:bodyPr wrap="square" lIns="0" tIns="0" rIns="0" bIns="0" rtlCol="0" anchor="ctr"/>
           <a:lstStyle/>
           <a:p>
-            <a:pPr marL="0" indent="0">
-              <a:buNone/>
-            </a:pPr>
             <a:r>
               <a:rPr lang="en-US" sz="1050" b="1" dirty="0">
                 <a:solidFill>
@@ -6099,9 +6843,6 @@
           <a:bodyPr wrap="square" lIns="0" tIns="0" rIns="0" bIns="0" rtlCol="0" anchor="ctr"/>
           <a:lstStyle/>
           <a:p>
-            <a:pPr marL="0" indent="0">
-              <a:buNone/>
-            </a:pPr>
             <a:r>
               <a:rPr lang="en-US" sz="850" dirty="0">
                 <a:solidFill>
@@ -6135,9 +6876,7 @@
           <a:bodyPr wrap="square" lIns="0" tIns="0" rIns="0" bIns="0" rtlCol="0" anchor="ctr"/>
           <a:lstStyle/>
           <a:p>
-            <a:pPr marL="0" indent="0" algn="ctr">
-              <a:buNone/>
-            </a:pPr>
+            <a:pPr algn="ctr"/>
             <a:r>
               <a:rPr lang="en-US" sz="1000" b="1" dirty="0">
                 <a:solidFill>
@@ -6185,7 +6924,7 @@
         </p:nvSpPr>
         <p:spPr>
           <a:xfrm>
-            <a:off x="6693408" y="3822192"/>
+            <a:off x="6693410" y="3822192"/>
             <a:ext cx="1512783" cy="109728"/>
           </a:xfrm>
           <a:prstGeom prst="rect">
@@ -6225,9 +6964,6 @@
           <a:bodyPr wrap="square" lIns="0" tIns="0" rIns="0" bIns="0" rtlCol="0" anchor="ctr"/>
           <a:lstStyle/>
           <a:p>
-            <a:pPr marL="0" indent="0">
-              <a:buNone/>
-            </a:pPr>
             <a:r>
               <a:rPr lang="en-US" sz="1000" b="1" dirty="0">
                 <a:solidFill>
@@ -6327,9 +7063,6 @@
           <a:bodyPr wrap="square" lIns="0" tIns="0" rIns="0" bIns="0" rtlCol="0" anchor="ctr"/>
           <a:lstStyle/>
           <a:p>
-            <a:pPr marL="0" indent="0">
-              <a:buNone/>
-            </a:pPr>
             <a:r>
               <a:rPr lang="en-US" sz="1050" b="1" dirty="0">
                 <a:solidFill>
@@ -6363,9 +7096,6 @@
           <a:bodyPr wrap="square" lIns="0" tIns="0" rIns="0" bIns="0" rtlCol="0" anchor="ctr"/>
           <a:lstStyle/>
           <a:p>
-            <a:pPr marL="0" indent="0">
-              <a:buNone/>
-            </a:pPr>
             <a:r>
               <a:rPr lang="en-US" sz="850" dirty="0">
                 <a:solidFill>
@@ -6399,9 +7129,7 @@
           <a:bodyPr wrap="square" lIns="0" tIns="0" rIns="0" bIns="0" rtlCol="0" anchor="ctr"/>
           <a:lstStyle/>
           <a:p>
-            <a:pPr marL="0" indent="0" algn="ctr">
-              <a:buNone/>
-            </a:pPr>
+            <a:pPr algn="ctr"/>
             <a:r>
               <a:rPr lang="en-US" sz="1000" b="1" dirty="0">
                 <a:solidFill>
@@ -6462,9 +7190,7 @@
           <a:bodyPr wrap="square" lIns="0" tIns="0" rIns="0" bIns="0" rtlCol="0" anchor="ctr"/>
           <a:lstStyle/>
           <a:p>
-            <a:pPr marL="0" indent="0" algn="ctr">
-              <a:buNone/>
-            </a:pPr>
+            <a:pPr algn="ctr"/>
             <a:r>
               <a:rPr lang="en-US" sz="800" dirty="0">
                 <a:solidFill>
@@ -6498,9 +7224,6 @@
           <a:bodyPr wrap="square" lIns="0" tIns="0" rIns="0" bIns="0" rtlCol="0" anchor="ctr"/>
           <a:lstStyle/>
           <a:p>
-            <a:pPr marL="0" indent="0">
-              <a:buNone/>
-            </a:pPr>
             <a:r>
               <a:rPr lang="en-US" sz="850" i="1" dirty="0">
                 <a:solidFill>
@@ -6524,14 +7247,6 @@
 <file path=ppt/slides/slide4.xml><?xml version="1.0" encoding="utf-8"?>
 <p:sld xmlns:a="http://schemas.openxmlformats.org/drawingml/2006/main" xmlns:r="http://schemas.openxmlformats.org/officeDocument/2006/relationships" xmlns:p="http://schemas.openxmlformats.org/presentationml/2006/main">
   <p:cSld name="Slide 4">
-    <p:bg>
-      <p:bgPr>
-        <a:solidFill>
-          <a:srgbClr val="0D1B2A"/>
-        </a:solidFill>
-        <a:effectLst/>
-      </p:bgPr>
-    </p:bg>
     <p:spTree>
       <p:nvGrpSpPr>
         <p:cNvPr id="1" name=""/>
@@ -6594,9 +7309,6 @@
           <a:bodyPr wrap="square" lIns="0" tIns="0" rIns="0" bIns="0" rtlCol="0" anchor="ctr"/>
           <a:lstStyle/>
           <a:p>
-            <a:pPr marL="0" indent="0">
-              <a:buNone/>
-            </a:pPr>
             <a:r>
               <a:rPr lang="en-US" sz="1100" b="1" kern="0" spc="300" dirty="0">
                 <a:solidFill>
@@ -6630,9 +7342,6 @@
           <a:bodyPr wrap="square" lIns="0" tIns="0" rIns="0" bIns="0" rtlCol="0" anchor="ctr"/>
           <a:lstStyle/>
           <a:p>
-            <a:pPr marL="0" indent="0">
-              <a:buNone/>
-            </a:pPr>
             <a:r>
               <a:rPr lang="en-US" sz="2200" b="1" dirty="0">
                 <a:solidFill>
@@ -6756,9 +7465,6 @@
           <a:bodyPr wrap="square" lIns="0" tIns="0" rIns="0" bIns="0" rtlCol="0" anchor="ctr"/>
           <a:lstStyle/>
           <a:p>
-            <a:pPr marL="0" indent="0">
-              <a:buNone/>
-            </a:pPr>
             <a:r>
               <a:rPr lang="en-US" sz="1300" b="1" dirty="0">
                 <a:solidFill>
@@ -6792,9 +7498,6 @@
           <a:bodyPr wrap="square" lIns="0" tIns="0" rIns="0" bIns="0" rtlCol="0" anchor="t"/>
           <a:lstStyle/>
           <a:p>
-            <a:pPr marL="0" indent="0">
-              <a:buNone/>
-            </a:pPr>
             <a:r>
               <a:rPr lang="en-US" sz="1100" dirty="0">
                 <a:solidFill>
@@ -6918,9 +7621,6 @@
           <a:bodyPr wrap="square" lIns="0" tIns="0" rIns="0" bIns="0" rtlCol="0" anchor="ctr"/>
           <a:lstStyle/>
           <a:p>
-            <a:pPr marL="0" indent="0">
-              <a:buNone/>
-            </a:pPr>
             <a:r>
               <a:rPr lang="en-US" sz="1300" b="1" dirty="0">
                 <a:solidFill>
@@ -6954,9 +7654,6 @@
           <a:bodyPr wrap="square" lIns="0" tIns="0" rIns="0" bIns="0" rtlCol="0" anchor="t"/>
           <a:lstStyle/>
           <a:p>
-            <a:pPr marL="0" indent="0">
-              <a:buNone/>
-            </a:pPr>
             <a:r>
               <a:rPr lang="en-US" sz="1100" dirty="0">
                 <a:solidFill>
@@ -7080,9 +7777,6 @@
           <a:bodyPr wrap="square" lIns="0" tIns="0" rIns="0" bIns="0" rtlCol="0" anchor="ctr"/>
           <a:lstStyle/>
           <a:p>
-            <a:pPr marL="0" indent="0">
-              <a:buNone/>
-            </a:pPr>
             <a:r>
               <a:rPr lang="en-US" sz="1300" b="1" dirty="0">
                 <a:solidFill>
@@ -7116,9 +7810,6 @@
           <a:bodyPr wrap="square" lIns="0" tIns="0" rIns="0" bIns="0" rtlCol="0" anchor="t"/>
           <a:lstStyle/>
           <a:p>
-            <a:pPr marL="0" indent="0">
-              <a:buNone/>
-            </a:pPr>
             <a:r>
               <a:rPr lang="en-US" sz="1100" dirty="0">
                 <a:solidFill>
@@ -7242,9 +7933,6 @@
           <a:bodyPr wrap="square" lIns="0" tIns="0" rIns="0" bIns="0" rtlCol="0" anchor="ctr"/>
           <a:lstStyle/>
           <a:p>
-            <a:pPr marL="0" indent="0">
-              <a:buNone/>
-            </a:pPr>
             <a:r>
               <a:rPr lang="en-US" sz="1300" b="1" dirty="0">
                 <a:solidFill>
@@ -7278,9 +7966,6 @@
           <a:bodyPr wrap="square" lIns="0" tIns="0" rIns="0" bIns="0" rtlCol="0" anchor="t"/>
           <a:lstStyle/>
           <a:p>
-            <a:pPr marL="0" indent="0">
-              <a:buNone/>
-            </a:pPr>
             <a:r>
               <a:rPr lang="en-US" sz="1100" dirty="0">
                 <a:solidFill>
@@ -7346,9 +8031,6 @@
           <a:bodyPr wrap="square" lIns="0" tIns="0" rIns="0" bIns="0" rtlCol="0" anchor="ctr"/>
           <a:lstStyle/>
           <a:p>
-            <a:pPr marL="0" indent="0">
-              <a:buNone/>
-            </a:pPr>
             <a:r>
               <a:rPr lang="en-US" sz="1000" b="1" dirty="0">
                 <a:solidFill>
@@ -7382,9 +8064,6 @@
           <a:bodyPr wrap="square" lIns="0" tIns="0" rIns="0" bIns="0" rtlCol="0" anchor="ctr"/>
           <a:lstStyle/>
           <a:p>
-            <a:pPr marL="0" indent="0">
-              <a:buNone/>
-            </a:pPr>
             <a:r>
               <a:rPr lang="en-US" sz="1000" dirty="0">
                 <a:solidFill>
@@ -7408,14 +8087,6 @@
 <file path=ppt/slides/slide5.xml><?xml version="1.0" encoding="utf-8"?>
 <p:sld xmlns:a="http://schemas.openxmlformats.org/drawingml/2006/main" xmlns:r="http://schemas.openxmlformats.org/officeDocument/2006/relationships" xmlns:p="http://schemas.openxmlformats.org/presentationml/2006/main">
   <p:cSld name="Slide 5">
-    <p:bg>
-      <p:bgPr>
-        <a:solidFill>
-          <a:srgbClr val="0D1B2A"/>
-        </a:solidFill>
-        <a:effectLst/>
-      </p:bgPr>
-    </p:bg>
     <p:spTree>
       <p:nvGrpSpPr>
         <p:cNvPr id="1" name=""/>
@@ -7478,9 +8149,6 @@
           <a:bodyPr wrap="square" lIns="0" tIns="0" rIns="0" bIns="0" rtlCol="0" anchor="ctr"/>
           <a:lstStyle/>
           <a:p>
-            <a:pPr marL="0" indent="0">
-              <a:buNone/>
-            </a:pPr>
             <a:r>
               <a:rPr lang="en-US" sz="1100" b="1" kern="0" spc="300" dirty="0">
                 <a:solidFill>
@@ -7514,9 +8182,6 @@
           <a:bodyPr wrap="square" lIns="0" tIns="0" rIns="0" bIns="0" rtlCol="0" anchor="ctr"/>
           <a:lstStyle/>
           <a:p>
-            <a:pPr marL="0" indent="0">
-              <a:buNone/>
-            </a:pPr>
             <a:r>
               <a:rPr lang="en-US" sz="2200" b="1" dirty="0">
                 <a:solidFill>
@@ -7645,9 +8310,7 @@
           <a:bodyPr wrap="square" lIns="0" tIns="0" rIns="0" bIns="0" rtlCol="0" anchor="ctr"/>
           <a:lstStyle/>
           <a:p>
-            <a:pPr marL="0" indent="0" algn="ctr">
-              <a:buNone/>
-            </a:pPr>
+            <a:pPr algn="ctr"/>
             <a:r>
               <a:rPr lang="en-US" sz="800" b="1" dirty="0">
                 <a:solidFill>
@@ -7705,9 +8368,6 @@
           <a:bodyPr wrap="square" lIns="0" tIns="0" rIns="0" bIns="0" rtlCol="0" anchor="ctr"/>
           <a:lstStyle/>
           <a:p>
-            <a:pPr marL="0" indent="0">
-              <a:buNone/>
-            </a:pPr>
             <a:r>
               <a:rPr lang="en-US" sz="1300" b="1" dirty="0">
                 <a:solidFill>
@@ -7741,9 +8401,6 @@
           <a:bodyPr wrap="square" lIns="0" tIns="0" rIns="0" bIns="0" rtlCol="0" anchor="ctr"/>
           <a:lstStyle/>
           <a:p>
-            <a:pPr marL="0" indent="0">
-              <a:buNone/>
-            </a:pPr>
             <a:r>
               <a:rPr lang="en-US" sz="900" dirty="0">
                 <a:solidFill>
@@ -7777,9 +8434,6 @@
           <a:bodyPr wrap="square" lIns="0" tIns="0" rIns="0" bIns="0" rtlCol="0" anchor="t"/>
           <a:lstStyle/>
           <a:p>
-            <a:pPr marL="0" indent="0">
-              <a:buNone/>
-            </a:pPr>
             <a:r>
               <a:rPr lang="en-US" sz="1050" dirty="0">
                 <a:solidFill>
@@ -7840,9 +8494,6 @@
           <a:bodyPr wrap="square" lIns="0" tIns="0" rIns="0" bIns="0" rtlCol="0" anchor="ctr"/>
           <a:lstStyle/>
           <a:p>
-            <a:pPr marL="0" indent="0">
-              <a:buNone/>
-            </a:pPr>
             <a:r>
               <a:rPr lang="en-US" sz="1000" dirty="0">
                 <a:solidFill>
@@ -7903,9 +8554,6 @@
           <a:bodyPr wrap="square" lIns="0" tIns="0" rIns="0" bIns="0" rtlCol="0" anchor="ctr"/>
           <a:lstStyle/>
           <a:p>
-            <a:pPr marL="0" indent="0">
-              <a:buNone/>
-            </a:pPr>
             <a:r>
               <a:rPr lang="en-US" sz="1000" dirty="0">
                 <a:solidFill>
@@ -7966,9 +8614,6 @@
           <a:bodyPr wrap="square" lIns="0" tIns="0" rIns="0" bIns="0" rtlCol="0" anchor="ctr"/>
           <a:lstStyle/>
           <a:p>
-            <a:pPr marL="0" indent="0">
-              <a:buNone/>
-            </a:pPr>
             <a:r>
               <a:rPr lang="en-US" sz="1000" dirty="0">
                 <a:solidFill>
@@ -8097,9 +8742,7 @@
           <a:bodyPr wrap="square" lIns="0" tIns="0" rIns="0" bIns="0" rtlCol="0" anchor="ctr"/>
           <a:lstStyle/>
           <a:p>
-            <a:pPr marL="0" indent="0" algn="ctr">
-              <a:buNone/>
-            </a:pPr>
+            <a:pPr algn="ctr"/>
             <a:r>
               <a:rPr lang="en-US" sz="800" b="1" dirty="0">
                 <a:solidFill>
@@ -8157,9 +8800,6 @@
           <a:bodyPr wrap="square" lIns="0" tIns="0" rIns="0" bIns="0" rtlCol="0" anchor="ctr"/>
           <a:lstStyle/>
           <a:p>
-            <a:pPr marL="0" indent="0">
-              <a:buNone/>
-            </a:pPr>
             <a:r>
               <a:rPr lang="en-US" sz="1300" b="1" dirty="0">
                 <a:solidFill>
@@ -8169,42 +8809,6 @@
               <a:t>Distributors &amp; Suppliers</a:t>
             </a:r>
             <a:endParaRPr lang="en-US" sz="1300" dirty="0"/>
-          </a:p>
-        </p:txBody>
-      </p:sp>
-      <p:sp>
-        <p:nvSpPr>
-          <p:cNvPr id="25" name="Text 21"/>
-          <p:cNvSpPr/>
-          <p:nvPr/>
-        </p:nvSpPr>
-        <p:spPr>
-          <a:xfrm>
-            <a:off x="3941064" y="2130552"/>
-            <a:ext cx="1783080" cy="201168"/>
-          </a:xfrm>
-          <a:prstGeom prst="rect">
-            <a:avLst/>
-          </a:prstGeom>
-          <a:noFill/>
-          <a:ln/>
-        </p:spPr>
-        <p:txBody>
-          <a:bodyPr wrap="square" lIns="0" tIns="0" rIns="0" bIns="0" rtlCol="0" anchor="ctr"/>
-          <a:lstStyle/>
-          <a:p>
-            <a:pPr marL="0" indent="0">
-              <a:buNone/>
-            </a:pPr>
-            <a:r>
-              <a:rPr lang="en-US" sz="900" dirty="0">
-                <a:solidFill>
-                  <a:srgbClr val="7A92A8"/>
-                </a:solidFill>
-              </a:rPr>
-              <a:t>Adjacent segment — Phase 2+</a:t>
-            </a:r>
-            <a:endParaRPr lang="en-US" sz="900" dirty="0"/>
           </a:p>
         </p:txBody>
       </p:sp>
@@ -8229,9 +8833,6 @@
           <a:bodyPr wrap="square" lIns="0" tIns="0" rIns="0" bIns="0" rtlCol="0" anchor="t"/>
           <a:lstStyle/>
           <a:p>
-            <a:pPr marL="0" indent="0">
-              <a:buNone/>
-            </a:pPr>
             <a:r>
               <a:rPr lang="en-US" sz="1050" dirty="0">
                 <a:solidFill>
@@ -8292,9 +8893,6 @@
           <a:bodyPr wrap="square" lIns="0" tIns="0" rIns="0" bIns="0" rtlCol="0" anchor="ctr"/>
           <a:lstStyle/>
           <a:p>
-            <a:pPr marL="0" indent="0">
-              <a:buNone/>
-            </a:pPr>
             <a:r>
               <a:rPr lang="en-US" sz="1000" dirty="0">
                 <a:solidFill>
@@ -8355,9 +8953,6 @@
           <a:bodyPr wrap="square" lIns="0" tIns="0" rIns="0" bIns="0" rtlCol="0" anchor="ctr"/>
           <a:lstStyle/>
           <a:p>
-            <a:pPr marL="0" indent="0">
-              <a:buNone/>
-            </a:pPr>
             <a:r>
               <a:rPr lang="en-US" sz="1000" dirty="0">
                 <a:solidFill>
@@ -8418,9 +9013,6 @@
           <a:bodyPr wrap="square" lIns="0" tIns="0" rIns="0" bIns="0" rtlCol="0" anchor="ctr"/>
           <a:lstStyle/>
           <a:p>
-            <a:pPr marL="0" indent="0">
-              <a:buNone/>
-            </a:pPr>
             <a:r>
               <a:rPr lang="en-US" sz="1000" dirty="0">
                 <a:solidFill>
@@ -8549,9 +9141,7 @@
           <a:bodyPr wrap="square" lIns="0" tIns="0" rIns="0" bIns="0" rtlCol="0" anchor="ctr"/>
           <a:lstStyle/>
           <a:p>
-            <a:pPr marL="0" indent="0" algn="ctr">
-              <a:buNone/>
-            </a:pPr>
+            <a:pPr algn="ctr"/>
             <a:r>
               <a:rPr lang="en-US" sz="800" b="1" dirty="0">
                 <a:solidFill>
@@ -8609,9 +9199,6 @@
           <a:bodyPr wrap="square" lIns="0" tIns="0" rIns="0" bIns="0" rtlCol="0" anchor="ctr"/>
           <a:lstStyle/>
           <a:p>
-            <a:pPr marL="0" indent="0">
-              <a:buNone/>
-            </a:pPr>
             <a:r>
               <a:rPr lang="en-US" sz="1300" b="1" dirty="0">
                 <a:solidFill>
@@ -8621,42 +9208,6 @@
               <a:t>Manufacturers' Reps</a:t>
             </a:r>
             <a:endParaRPr lang="en-US" sz="1300" dirty="0"/>
-          </a:p>
-        </p:txBody>
-      </p:sp>
-      <p:sp>
-        <p:nvSpPr>
-          <p:cNvPr id="39" name="Text 34"/>
-          <p:cNvSpPr/>
-          <p:nvPr/>
-        </p:nvSpPr>
-        <p:spPr>
-          <a:xfrm>
-            <a:off x="6748272" y="2130552"/>
-            <a:ext cx="1783080" cy="201168"/>
-          </a:xfrm>
-          <a:prstGeom prst="rect">
-            <a:avLst/>
-          </a:prstGeom>
-          <a:noFill/>
-          <a:ln/>
-        </p:spPr>
-        <p:txBody>
-          <a:bodyPr wrap="square" lIns="0" tIns="0" rIns="0" bIns="0" rtlCol="0" anchor="ctr"/>
-          <a:lstStyle/>
-          <a:p>
-            <a:pPr marL="0" indent="0">
-              <a:buNone/>
-            </a:pPr>
-            <a:r>
-              <a:rPr lang="en-US" sz="900" dirty="0">
-                <a:solidFill>
-                  <a:srgbClr val="7A92A8"/>
-                </a:solidFill>
-              </a:rPr>
-              <a:t>Adjacent segment — Phase 2+</a:t>
-            </a:r>
-            <a:endParaRPr lang="en-US" sz="900" dirty="0"/>
           </a:p>
         </p:txBody>
       </p:sp>
@@ -8681,9 +9232,6 @@
           <a:bodyPr wrap="square" lIns="0" tIns="0" rIns="0" bIns="0" rtlCol="0" anchor="t"/>
           <a:lstStyle/>
           <a:p>
-            <a:pPr marL="0" indent="0">
-              <a:buNone/>
-            </a:pPr>
             <a:r>
               <a:rPr lang="en-US" sz="1050" dirty="0">
                 <a:solidFill>
@@ -8744,9 +9292,6 @@
           <a:bodyPr wrap="square" lIns="0" tIns="0" rIns="0" bIns="0" rtlCol="0" anchor="ctr"/>
           <a:lstStyle/>
           <a:p>
-            <a:pPr marL="0" indent="0">
-              <a:buNone/>
-            </a:pPr>
             <a:r>
               <a:rPr lang="en-US" sz="1000" dirty="0">
                 <a:solidFill>
@@ -8807,9 +9352,6 @@
           <a:bodyPr wrap="square" lIns="0" tIns="0" rIns="0" bIns="0" rtlCol="0" anchor="ctr"/>
           <a:lstStyle/>
           <a:p>
-            <a:pPr marL="0" indent="0">
-              <a:buNone/>
-            </a:pPr>
             <a:r>
               <a:rPr lang="en-US" sz="1000" dirty="0">
                 <a:solidFill>
@@ -8870,9 +9412,6 @@
           <a:bodyPr wrap="square" lIns="0" tIns="0" rIns="0" bIns="0" rtlCol="0" anchor="ctr"/>
           <a:lstStyle/>
           <a:p>
-            <a:pPr marL="0" indent="0">
-              <a:buNone/>
-            </a:pPr>
             <a:r>
               <a:rPr lang="en-US" sz="1000" dirty="0">
                 <a:solidFill>
@@ -8938,9 +9477,7 @@
           <a:bodyPr wrap="square" lIns="0" tIns="0" rIns="0" bIns="0" rtlCol="0" anchor="ctr"/>
           <a:lstStyle/>
           <a:p>
-            <a:pPr marL="0" indent="0" algn="ctr">
-              <a:buNone/>
-            </a:pPr>
+            <a:pPr algn="ctr"/>
             <a:r>
               <a:rPr lang="en-US" sz="800" i="1" dirty="0">
                 <a:solidFill>
@@ -8964,14 +9501,6 @@
 <file path=ppt/slides/slide6.xml><?xml version="1.0" encoding="utf-8"?>
 <p:sld xmlns:a="http://schemas.openxmlformats.org/drawingml/2006/main" xmlns:r="http://schemas.openxmlformats.org/officeDocument/2006/relationships" xmlns:p="http://schemas.openxmlformats.org/presentationml/2006/main">
   <p:cSld name="Slide 6">
-    <p:bg>
-      <p:bgPr>
-        <a:solidFill>
-          <a:srgbClr val="0D1B2A"/>
-        </a:solidFill>
-        <a:effectLst/>
-      </p:bgPr>
-    </p:bg>
     <p:spTree>
       <p:nvGrpSpPr>
         <p:cNvPr id="1" name=""/>
@@ -9034,9 +9563,6 @@
           <a:bodyPr wrap="square" lIns="0" tIns="0" rIns="0" bIns="0" rtlCol="0" anchor="ctr"/>
           <a:lstStyle/>
           <a:p>
-            <a:pPr marL="0" indent="0">
-              <a:buNone/>
-            </a:pPr>
             <a:r>
               <a:rPr lang="en-US" sz="1100" b="1" kern="0" spc="300" dirty="0">
                 <a:solidFill>
@@ -9070,32 +9596,26 @@
           <a:bodyPr wrap="square" lIns="0" tIns="0" rIns="0" bIns="0" rtlCol="0" anchor="ctr"/>
           <a:lstStyle/>
           <a:p>
-            <a:pPr marL="0" indent="0">
-              <a:buNone/>
-            </a:pPr>
-            <a:r>
-              <a:rPr lang="en-US" sz="1800" b="1" dirty="0">
+            <a:r>
+              <a:rPr lang="en-US" b="1" dirty="0">
                 <a:solidFill>
                   <a:srgbClr val="FFFFFF"/>
                 </a:solidFill>
               </a:rPr>
               <a:t>Generic AI can read a PDF. The advantage is what accumulates</a:t>
             </a:r>
-            <a:endParaRPr lang="en-US" sz="1800" dirty="0"/>
-          </a:p>
-          <a:p>
-            <a:pPr marL="0" indent="0">
-              <a:buNone/>
-            </a:pPr>
-            <a:r>
-              <a:rPr lang="en-US" sz="1800" b="1" dirty="0">
+            <a:endParaRPr lang="en-US" dirty="0"/>
+          </a:p>
+          <a:p>
+            <a:r>
+              <a:rPr lang="en-US" b="1" dirty="0">
                 <a:solidFill>
                   <a:srgbClr val="FFFFFF"/>
                 </a:solidFill>
               </a:rPr>
               <a:t>when estimators score bids, log outcomes, and refine decisions over time.</a:t>
             </a:r>
-            <a:endParaRPr lang="en-US" sz="1800" dirty="0"/>
+            <a:endParaRPr lang="en-US" dirty="0"/>
           </a:p>
         </p:txBody>
       </p:sp>
@@ -9215,9 +9735,7 @@
           <a:bodyPr wrap="square" lIns="0" tIns="0" rIns="0" bIns="0" rtlCol="0" anchor="ctr"/>
           <a:lstStyle/>
           <a:p>
-            <a:pPr marL="0" indent="0" algn="ctr">
-              <a:buNone/>
-            </a:pPr>
+            <a:pPr algn="ctr"/>
             <a:r>
               <a:rPr lang="en-US" sz="750" b="1" dirty="0">
                 <a:solidFill>
@@ -9275,9 +9793,6 @@
           <a:bodyPr wrap="square" lIns="0" tIns="0" rIns="0" bIns="0" rtlCol="0" anchor="ctr"/>
           <a:lstStyle/>
           <a:p>
-            <a:pPr marL="0" indent="0">
-              <a:buNone/>
-            </a:pPr>
             <a:r>
               <a:rPr lang="en-US" sz="1400" b="1" dirty="0">
                 <a:solidFill>
@@ -9338,9 +9853,6 @@
           <a:bodyPr wrap="square" lIns="0" tIns="0" rIns="0" bIns="0" rtlCol="0" anchor="t"/>
           <a:lstStyle/>
           <a:p>
-            <a:pPr marL="0" indent="0">
-              <a:buNone/>
-            </a:pPr>
             <a:r>
               <a:rPr lang="en-US" sz="1050" dirty="0">
                 <a:solidFill>
@@ -9401,9 +9913,6 @@
           <a:bodyPr wrap="square" lIns="0" tIns="0" rIns="0" bIns="0" rtlCol="0" anchor="ctr"/>
           <a:lstStyle/>
           <a:p>
-            <a:pPr marL="0" indent="0">
-              <a:buNone/>
-            </a:pPr>
             <a:r>
               <a:rPr lang="en-US" sz="900" dirty="0">
                 <a:solidFill>
@@ -9532,9 +10041,7 @@
           <a:bodyPr wrap="square" lIns="0" tIns="0" rIns="0" bIns="0" rtlCol="0" anchor="ctr"/>
           <a:lstStyle/>
           <a:p>
-            <a:pPr marL="0" indent="0" algn="ctr">
-              <a:buNone/>
-            </a:pPr>
+            <a:pPr algn="ctr"/>
             <a:r>
               <a:rPr lang="en-US" sz="750" b="1" dirty="0">
                 <a:solidFill>
@@ -9592,9 +10099,6 @@
           <a:bodyPr wrap="square" lIns="0" tIns="0" rIns="0" bIns="0" rtlCol="0" anchor="ctr"/>
           <a:lstStyle/>
           <a:p>
-            <a:pPr marL="0" indent="0">
-              <a:buNone/>
-            </a:pPr>
             <a:r>
               <a:rPr lang="en-US" sz="1400" b="1" dirty="0">
                 <a:solidFill>
@@ -9655,9 +10159,6 @@
           <a:bodyPr wrap="square" lIns="0" tIns="0" rIns="0" bIns="0" rtlCol="0" anchor="t"/>
           <a:lstStyle/>
           <a:p>
-            <a:pPr marL="0" indent="0">
-              <a:buNone/>
-            </a:pPr>
             <a:r>
               <a:rPr lang="en-US" sz="1050" dirty="0">
                 <a:solidFill>
@@ -9718,9 +10219,6 @@
           <a:bodyPr wrap="square" lIns="0" tIns="0" rIns="0" bIns="0" rtlCol="0" anchor="ctr"/>
           <a:lstStyle/>
           <a:p>
-            <a:pPr marL="0" indent="0">
-              <a:buNone/>
-            </a:pPr>
             <a:r>
               <a:rPr lang="en-US" sz="900" dirty="0">
                 <a:solidFill>
@@ -9849,9 +10347,7 @@
           <a:bodyPr wrap="square" lIns="0" tIns="0" rIns="0" bIns="0" rtlCol="0" anchor="ctr"/>
           <a:lstStyle/>
           <a:p>
-            <a:pPr marL="0" indent="0" algn="ctr">
-              <a:buNone/>
-            </a:pPr>
+            <a:pPr algn="ctr"/>
             <a:r>
               <a:rPr lang="en-US" sz="750" b="1" dirty="0">
                 <a:solidFill>
@@ -9909,9 +10405,6 @@
           <a:bodyPr wrap="square" lIns="0" tIns="0" rIns="0" bIns="0" rtlCol="0" anchor="ctr"/>
           <a:lstStyle/>
           <a:p>
-            <a:pPr marL="0" indent="0">
-              <a:buNone/>
-            </a:pPr>
             <a:r>
               <a:rPr lang="en-US" sz="1400" b="1" dirty="0">
                 <a:solidFill>
@@ -9972,9 +10465,6 @@
           <a:bodyPr wrap="square" lIns="0" tIns="0" rIns="0" bIns="0" rtlCol="0" anchor="t"/>
           <a:lstStyle/>
           <a:p>
-            <a:pPr marL="0" indent="0">
-              <a:buNone/>
-            </a:pPr>
             <a:r>
               <a:rPr lang="en-US" sz="1050" dirty="0">
                 <a:solidFill>
@@ -10035,9 +10525,6 @@
           <a:bodyPr wrap="square" lIns="0" tIns="0" rIns="0" bIns="0" rtlCol="0" anchor="ctr"/>
           <a:lstStyle/>
           <a:p>
-            <a:pPr marL="0" indent="0">
-              <a:buNone/>
-            </a:pPr>
             <a:r>
               <a:rPr lang="en-US" sz="900" dirty="0">
                 <a:solidFill>
@@ -10098,9 +10585,7 @@
           <a:bodyPr wrap="square" lIns="0" tIns="0" rIns="0" bIns="0" rtlCol="0" anchor="ctr"/>
           <a:lstStyle/>
           <a:p>
-            <a:pPr marL="0" indent="0" algn="ctr">
-              <a:buNone/>
-            </a:pPr>
+            <a:pPr algn="ctr"/>
             <a:r>
               <a:rPr lang="en-US" sz="1000" b="1" dirty="0">
                 <a:solidFill>
@@ -10124,14 +10609,6 @@
 <file path=ppt/slides/slide7.xml><?xml version="1.0" encoding="utf-8"?>
 <p:sld xmlns:a="http://schemas.openxmlformats.org/drawingml/2006/main" xmlns:r="http://schemas.openxmlformats.org/officeDocument/2006/relationships" xmlns:p="http://schemas.openxmlformats.org/presentationml/2006/main">
   <p:cSld name="Slide 7">
-    <p:bg>
-      <p:bgPr>
-        <a:solidFill>
-          <a:srgbClr val="0D1B2A"/>
-        </a:solidFill>
-        <a:effectLst/>
-      </p:bgPr>
-    </p:bg>
     <p:spTree>
       <p:nvGrpSpPr>
         <p:cNvPr id="1" name=""/>
@@ -10194,9 +10671,6 @@
           <a:bodyPr wrap="square" lIns="0" tIns="0" rIns="0" bIns="0" rtlCol="0" anchor="ctr"/>
           <a:lstStyle/>
           <a:p>
-            <a:pPr marL="0" indent="0">
-              <a:buNone/>
-            </a:pPr>
             <a:r>
               <a:rPr lang="en-US" sz="1100" b="1" kern="0" spc="300" dirty="0">
                 <a:solidFill>
@@ -10230,9 +10704,6 @@
           <a:bodyPr wrap="square" lIns="0" tIns="0" rIns="0" bIns="0" rtlCol="0" anchor="ctr"/>
           <a:lstStyle/>
           <a:p>
-            <a:pPr marL="0" indent="0">
-              <a:buNone/>
-            </a:pPr>
             <a:r>
               <a:rPr lang="en-US" sz="2200" b="1" dirty="0">
                 <a:solidFill>
@@ -10293,9 +10764,7 @@
           <a:bodyPr wrap="square" lIns="0" tIns="0" rIns="0" bIns="0" rtlCol="0" anchor="ctr"/>
           <a:lstStyle/>
           <a:p>
-            <a:pPr marL="0" indent="0" algn="ctr">
-              <a:buNone/>
-            </a:pPr>
+            <a:pPr algn="ctr"/>
             <a:r>
               <a:rPr lang="en-US" sz="1400" b="1" dirty="0">
                 <a:solidFill>
@@ -10329,9 +10798,6 @@
           <a:bodyPr wrap="square" lIns="0" tIns="0" rIns="0" bIns="0" rtlCol="0" anchor="ctr"/>
           <a:lstStyle/>
           <a:p>
-            <a:pPr marL="0" indent="0">
-              <a:buNone/>
-            </a:pPr>
             <a:r>
               <a:rPr lang="en-US" sz="1200" b="1" dirty="0">
                 <a:solidFill>
@@ -10365,9 +10831,6 @@
           <a:bodyPr wrap="square" lIns="0" tIns="0" rIns="0" bIns="0" rtlCol="0" anchor="ctr"/>
           <a:lstStyle/>
           <a:p>
-            <a:pPr marL="0" indent="0">
-              <a:buNone/>
-            </a:pPr>
             <a:r>
               <a:rPr lang="en-US" sz="1000" dirty="0">
                 <a:solidFill>
@@ -10455,9 +10918,7 @@
           <a:bodyPr wrap="square" lIns="0" tIns="0" rIns="0" bIns="0" rtlCol="0" anchor="ctr"/>
           <a:lstStyle/>
           <a:p>
-            <a:pPr marL="0" indent="0" algn="ctr">
-              <a:buNone/>
-            </a:pPr>
+            <a:pPr algn="ctr"/>
             <a:r>
               <a:rPr lang="en-US" sz="1400" b="1" dirty="0">
                 <a:solidFill>
@@ -10491,9 +10952,6 @@
           <a:bodyPr wrap="square" lIns="0" tIns="0" rIns="0" bIns="0" rtlCol="0" anchor="ctr"/>
           <a:lstStyle/>
           <a:p>
-            <a:pPr marL="0" indent="0">
-              <a:buNone/>
-            </a:pPr>
             <a:r>
               <a:rPr lang="en-US" sz="1200" b="1" dirty="0">
                 <a:solidFill>
@@ -10527,9 +10985,6 @@
           <a:bodyPr wrap="square" lIns="0" tIns="0" rIns="0" bIns="0" rtlCol="0" anchor="ctr"/>
           <a:lstStyle/>
           <a:p>
-            <a:pPr marL="0" indent="0">
-              <a:buNone/>
-            </a:pPr>
             <a:r>
               <a:rPr lang="en-US" sz="1000" dirty="0">
                 <a:solidFill>
@@ -10617,9 +11072,7 @@
           <a:bodyPr wrap="square" lIns="0" tIns="0" rIns="0" bIns="0" rtlCol="0" anchor="ctr"/>
           <a:lstStyle/>
           <a:p>
-            <a:pPr marL="0" indent="0" algn="ctr">
-              <a:buNone/>
-            </a:pPr>
+            <a:pPr algn="ctr"/>
             <a:r>
               <a:rPr lang="en-US" sz="1400" b="1" dirty="0">
                 <a:solidFill>
@@ -10653,9 +11106,6 @@
           <a:bodyPr wrap="square" lIns="0" tIns="0" rIns="0" bIns="0" rtlCol="0" anchor="ctr"/>
           <a:lstStyle/>
           <a:p>
-            <a:pPr marL="0" indent="0">
-              <a:buNone/>
-            </a:pPr>
             <a:r>
               <a:rPr lang="en-US" sz="1200" b="1" dirty="0">
                 <a:solidFill>
@@ -10689,9 +11139,6 @@
           <a:bodyPr wrap="square" lIns="0" tIns="0" rIns="0" bIns="0" rtlCol="0" anchor="ctr"/>
           <a:lstStyle/>
           <a:p>
-            <a:pPr marL="0" indent="0">
-              <a:buNone/>
-            </a:pPr>
             <a:r>
               <a:rPr lang="en-US" sz="1000" dirty="0">
                 <a:solidFill>
@@ -10779,9 +11226,7 @@
           <a:bodyPr wrap="square" lIns="0" tIns="0" rIns="0" bIns="0" rtlCol="0" anchor="ctr"/>
           <a:lstStyle/>
           <a:p>
-            <a:pPr marL="0" indent="0" algn="ctr">
-              <a:buNone/>
-            </a:pPr>
+            <a:pPr algn="ctr"/>
             <a:r>
               <a:rPr lang="en-US" sz="1400" b="1" dirty="0">
                 <a:solidFill>
@@ -10815,9 +11260,6 @@
           <a:bodyPr wrap="square" lIns="0" tIns="0" rIns="0" bIns="0" rtlCol="0" anchor="ctr"/>
           <a:lstStyle/>
           <a:p>
-            <a:pPr marL="0" indent="0">
-              <a:buNone/>
-            </a:pPr>
             <a:r>
               <a:rPr lang="en-US" sz="1200" b="1" dirty="0">
                 <a:solidFill>
@@ -10851,9 +11293,6 @@
           <a:bodyPr wrap="square" lIns="0" tIns="0" rIns="0" bIns="0" rtlCol="0" anchor="ctr"/>
           <a:lstStyle/>
           <a:p>
-            <a:pPr marL="0" indent="0">
-              <a:buNone/>
-            </a:pPr>
             <a:r>
               <a:rPr lang="en-US" sz="1000" dirty="0">
                 <a:solidFill>
@@ -10941,9 +11380,7 @@
           <a:bodyPr wrap="square" lIns="0" tIns="0" rIns="0" bIns="0" rtlCol="0" anchor="ctr"/>
           <a:lstStyle/>
           <a:p>
-            <a:pPr marL="0" indent="0" algn="ctr">
-              <a:buNone/>
-            </a:pPr>
+            <a:pPr algn="ctr"/>
             <a:r>
               <a:rPr lang="en-US" sz="1400" b="1" dirty="0">
                 <a:solidFill>
@@ -10977,9 +11414,6 @@
           <a:bodyPr wrap="square" lIns="0" tIns="0" rIns="0" bIns="0" rtlCol="0" anchor="ctr"/>
           <a:lstStyle/>
           <a:p>
-            <a:pPr marL="0" indent="0">
-              <a:buNone/>
-            </a:pPr>
             <a:r>
               <a:rPr lang="en-US" sz="1200" b="1" dirty="0">
                 <a:solidFill>
@@ -11013,9 +11447,6 @@
           <a:bodyPr wrap="square" lIns="0" tIns="0" rIns="0" bIns="0" rtlCol="0" anchor="ctr"/>
           <a:lstStyle/>
           <a:p>
-            <a:pPr marL="0" indent="0">
-              <a:buNone/>
-            </a:pPr>
             <a:r>
               <a:rPr lang="en-US" sz="1000" dirty="0">
                 <a:solidFill>
@@ -11115,9 +11546,6 @@
           <a:bodyPr wrap="square" lIns="0" tIns="0" rIns="0" bIns="0" rtlCol="0" anchor="ctr"/>
           <a:lstStyle/>
           <a:p>
-            <a:pPr marL="0" indent="0">
-              <a:buNone/>
-            </a:pPr>
             <a:r>
               <a:rPr lang="en-US" sz="1200" b="1" dirty="0">
                 <a:solidFill>
@@ -11190,9 +11618,6 @@
           <a:bodyPr wrap="square" lIns="0" tIns="0" rIns="0" bIns="0" rtlCol="0" anchor="ctr"/>
           <a:lstStyle/>
           <a:p>
-            <a:pPr marL="0" indent="0">
-              <a:buNone/>
-            </a:pPr>
             <a:r>
               <a:rPr lang="en-US" sz="1000" b="1" dirty="0">
                 <a:solidFill>
@@ -11226,9 +11651,6 @@
           <a:bodyPr wrap="square" lIns="0" tIns="0" rIns="0" bIns="0" rtlCol="0" anchor="ctr"/>
           <a:lstStyle/>
           <a:p>
-            <a:pPr marL="0" indent="0">
-              <a:buNone/>
-            </a:pPr>
             <a:r>
               <a:rPr lang="en-US" sz="900" dirty="0">
                 <a:solidFill>
@@ -11301,9 +11723,6 @@
           <a:bodyPr wrap="square" lIns="0" tIns="0" rIns="0" bIns="0" rtlCol="0" anchor="ctr"/>
           <a:lstStyle/>
           <a:p>
-            <a:pPr marL="0" indent="0">
-              <a:buNone/>
-            </a:pPr>
             <a:r>
               <a:rPr lang="en-US" sz="1000" b="1" dirty="0">
                 <a:solidFill>
@@ -11337,9 +11756,6 @@
           <a:bodyPr wrap="square" lIns="0" tIns="0" rIns="0" bIns="0" rtlCol="0" anchor="ctr"/>
           <a:lstStyle/>
           <a:p>
-            <a:pPr marL="0" indent="0">
-              <a:buNone/>
-            </a:pPr>
             <a:r>
               <a:rPr lang="en-US" sz="900" dirty="0">
                 <a:solidFill>
@@ -11412,9 +11828,6 @@
           <a:bodyPr wrap="square" lIns="0" tIns="0" rIns="0" bIns="0" rtlCol="0" anchor="ctr"/>
           <a:lstStyle/>
           <a:p>
-            <a:pPr marL="0" indent="0">
-              <a:buNone/>
-            </a:pPr>
             <a:r>
               <a:rPr lang="en-US" sz="1000" b="1" dirty="0">
                 <a:solidFill>
@@ -11448,9 +11861,6 @@
           <a:bodyPr wrap="square" lIns="0" tIns="0" rIns="0" bIns="0" rtlCol="0" anchor="ctr"/>
           <a:lstStyle/>
           <a:p>
-            <a:pPr marL="0" indent="0">
-              <a:buNone/>
-            </a:pPr>
             <a:r>
               <a:rPr lang="en-US" sz="900" dirty="0">
                 <a:solidFill>
@@ -11523,9 +11933,6 @@
           <a:bodyPr wrap="square" lIns="0" tIns="0" rIns="0" bIns="0" rtlCol="0" anchor="ctr"/>
           <a:lstStyle/>
           <a:p>
-            <a:pPr marL="0" indent="0">
-              <a:buNone/>
-            </a:pPr>
             <a:r>
               <a:rPr lang="en-US" sz="1000" b="1" dirty="0">
                 <a:solidFill>
@@ -11559,9 +11966,6 @@
           <a:bodyPr wrap="square" lIns="0" tIns="0" rIns="0" bIns="0" rtlCol="0" anchor="ctr"/>
           <a:lstStyle/>
           <a:p>
-            <a:pPr marL="0" indent="0">
-              <a:buNone/>
-            </a:pPr>
             <a:r>
               <a:rPr lang="en-US" sz="900" dirty="0">
                 <a:solidFill>
@@ -11634,9 +12038,6 @@
           <a:bodyPr wrap="square" lIns="0" tIns="0" rIns="0" bIns="0" rtlCol="0" anchor="ctr"/>
           <a:lstStyle/>
           <a:p>
-            <a:pPr marL="0" indent="0">
-              <a:buNone/>
-            </a:pPr>
             <a:r>
               <a:rPr lang="en-US" sz="1000" b="1" dirty="0">
                 <a:solidFill>
@@ -11670,9 +12071,6 @@
           <a:bodyPr wrap="square" lIns="0" tIns="0" rIns="0" bIns="0" rtlCol="0" anchor="ctr"/>
           <a:lstStyle/>
           <a:p>
-            <a:pPr marL="0" indent="0">
-              <a:buNone/>
-            </a:pPr>
             <a:r>
               <a:rPr lang="en-US" sz="900" dirty="0">
                 <a:solidFill>
@@ -11696,14 +12094,6 @@
 <file path=ppt/slides/slide8.xml><?xml version="1.0" encoding="utf-8"?>
 <p:sld xmlns:a="http://schemas.openxmlformats.org/drawingml/2006/main" xmlns:r="http://schemas.openxmlformats.org/officeDocument/2006/relationships" xmlns:p="http://schemas.openxmlformats.org/presentationml/2006/main">
   <p:cSld name="Slide 8">
-    <p:bg>
-      <p:bgPr>
-        <a:solidFill>
-          <a:srgbClr val="0D1B2A"/>
-        </a:solidFill>
-        <a:effectLst/>
-      </p:bgPr>
-    </p:bg>
     <p:spTree>
       <p:nvGrpSpPr>
         <p:cNvPr id="1" name=""/>
@@ -11766,9 +12156,6 @@
           <a:bodyPr wrap="square" lIns="0" tIns="0" rIns="0" bIns="0" rtlCol="0" anchor="ctr"/>
           <a:lstStyle/>
           <a:p>
-            <a:pPr marL="0" indent="0">
-              <a:buNone/>
-            </a:pPr>
             <a:r>
               <a:rPr lang="en-US" sz="1100" b="1" kern="0" spc="300" dirty="0">
                 <a:solidFill>
@@ -11802,9 +12189,6 @@
           <a:bodyPr wrap="square" lIns="0" tIns="0" rIns="0" bIns="0" rtlCol="0" anchor="ctr"/>
           <a:lstStyle/>
           <a:p>
-            <a:pPr marL="0" indent="0">
-              <a:buNone/>
-            </a:pPr>
             <a:r>
               <a:rPr lang="en-US" sz="1500" b="1" dirty="0">
                 <a:solidFill>
@@ -11865,9 +12249,6 @@
           <a:bodyPr wrap="square" lIns="0" tIns="0" rIns="0" bIns="0" rtlCol="0" anchor="ctr"/>
           <a:lstStyle/>
           <a:p>
-            <a:pPr marL="0" indent="0">
-              <a:buNone/>
-            </a:pPr>
             <a:r>
               <a:rPr lang="en-US" sz="1050" dirty="0">
                 <a:solidFill>
@@ -11928,9 +12309,6 @@
           <a:bodyPr wrap="square" lIns="0" tIns="0" rIns="0" bIns="0" rtlCol="0" anchor="ctr"/>
           <a:lstStyle/>
           <a:p>
-            <a:pPr marL="0" indent="0">
-              <a:buNone/>
-            </a:pPr>
             <a:r>
               <a:rPr lang="en-US" sz="1050" dirty="0">
                 <a:solidFill>
@@ -11991,9 +12369,6 @@
           <a:bodyPr wrap="square" lIns="0" tIns="0" rIns="0" bIns="0" rtlCol="0" anchor="ctr"/>
           <a:lstStyle/>
           <a:p>
-            <a:pPr marL="0" indent="0">
-              <a:buNone/>
-            </a:pPr>
             <a:r>
               <a:rPr lang="en-US" sz="1050" dirty="0">
                 <a:solidFill>
@@ -12054,9 +12429,6 @@
           <a:bodyPr wrap="square" lIns="0" tIns="0" rIns="0" bIns="0" rtlCol="0" anchor="ctr"/>
           <a:lstStyle/>
           <a:p>
-            <a:pPr marL="0" indent="0">
-              <a:buNone/>
-            </a:pPr>
             <a:r>
               <a:rPr lang="en-US" sz="1050" dirty="0">
                 <a:solidFill>
@@ -12117,9 +12489,6 @@
           <a:bodyPr wrap="square" lIns="0" tIns="0" rIns="0" bIns="0" rtlCol="0" anchor="ctr"/>
           <a:lstStyle/>
           <a:p>
-            <a:pPr marL="0" indent="0">
-              <a:buNone/>
-            </a:pPr>
             <a:r>
               <a:rPr lang="en-US" sz="1050" dirty="0">
                 <a:solidFill>
@@ -12180,9 +12549,6 @@
           <a:bodyPr wrap="square" lIns="0" tIns="0" rIns="0" bIns="0" rtlCol="0" anchor="ctr"/>
           <a:lstStyle/>
           <a:p>
-            <a:pPr marL="0" indent="0">
-              <a:buNone/>
-            </a:pPr>
             <a:r>
               <a:rPr lang="en-US" sz="1050" dirty="0">
                 <a:solidFill>
@@ -12243,9 +12609,6 @@
           <a:bodyPr wrap="square" lIns="0" tIns="0" rIns="0" bIns="0" rtlCol="0" anchor="ctr"/>
           <a:lstStyle/>
           <a:p>
-            <a:pPr marL="0" indent="0">
-              <a:buNone/>
-            </a:pPr>
             <a:r>
               <a:rPr lang="en-US" sz="1050" dirty="0">
                 <a:solidFill>
@@ -12306,9 +12669,6 @@
           <a:bodyPr wrap="square" lIns="0" tIns="0" rIns="0" bIns="0" rtlCol="0" anchor="ctr"/>
           <a:lstStyle/>
           <a:p>
-            <a:pPr marL="0" indent="0">
-              <a:buNone/>
-            </a:pPr>
             <a:r>
               <a:rPr lang="en-US" sz="1050" dirty="0">
                 <a:solidFill>
@@ -12408,9 +12768,6 @@
           <a:bodyPr wrap="square" lIns="0" tIns="0" rIns="0" bIns="0" rtlCol="0" anchor="ctr"/>
           <a:lstStyle/>
           <a:p>
-            <a:pPr marL="0" indent="0">
-              <a:buNone/>
-            </a:pPr>
             <a:r>
               <a:rPr lang="en-US" sz="1400" b="1" dirty="0">
                 <a:solidFill>
@@ -12483,9 +12840,6 @@
           <a:bodyPr wrap="square" lIns="0" tIns="0" rIns="0" bIns="0" rtlCol="0" anchor="ctr"/>
           <a:lstStyle/>
           <a:p>
-            <a:pPr marL="0" indent="0">
-              <a:buNone/>
-            </a:pPr>
             <a:r>
               <a:rPr lang="en-US" sz="1400" b="1" dirty="0">
                 <a:solidFill>
@@ -12519,9 +12873,6 @@
           <a:bodyPr wrap="square" lIns="0" tIns="0" rIns="0" bIns="0" rtlCol="0" anchor="ctr"/>
           <a:lstStyle/>
           <a:p>
-            <a:pPr marL="0" indent="0">
-              <a:buNone/>
-            </a:pPr>
             <a:r>
               <a:rPr lang="en-US" sz="1000" dirty="0">
                 <a:solidFill>
@@ -12555,9 +12906,7 @@
           <a:bodyPr wrap="square" lIns="0" tIns="0" rIns="0" bIns="0" rtlCol="0" anchor="ctr"/>
           <a:lstStyle/>
           <a:p>
-            <a:pPr marL="0" indent="0" algn="r">
-              <a:buNone/>
-            </a:pPr>
+            <a:pPr algn="r"/>
             <a:r>
               <a:rPr lang="en-US" sz="2000" b="1" dirty="0">
                 <a:solidFill>
@@ -12591,9 +12940,7 @@
           <a:bodyPr wrap="square" lIns="0" tIns="0" rIns="0" bIns="0" rtlCol="0" anchor="ctr"/>
           <a:lstStyle/>
           <a:p>
-            <a:pPr marL="0" indent="0" algn="r">
-              <a:buNone/>
-            </a:pPr>
+            <a:pPr algn="r"/>
             <a:r>
               <a:rPr lang="en-US" sz="900" dirty="0">
                 <a:solidFill>
@@ -12627,9 +12974,6 @@
           <a:bodyPr wrap="square" lIns="0" tIns="0" rIns="0" bIns="0" rtlCol="0" anchor="ctr"/>
           <a:lstStyle/>
           <a:p>
-            <a:pPr marL="0" indent="0">
-              <a:buNone/>
-            </a:pPr>
             <a:r>
               <a:rPr lang="en-US" sz="900" dirty="0">
                 <a:solidFill>
@@ -12702,9 +13046,6 @@
           <a:bodyPr wrap="square" lIns="0" tIns="0" rIns="0" bIns="0" rtlCol="0" anchor="ctr"/>
           <a:lstStyle/>
           <a:p>
-            <a:pPr marL="0" indent="0">
-              <a:buNone/>
-            </a:pPr>
             <a:r>
               <a:rPr lang="en-US" sz="1400" b="1" dirty="0">
                 <a:solidFill>
@@ -12738,9 +13079,6 @@
           <a:bodyPr wrap="square" lIns="0" tIns="0" rIns="0" bIns="0" rtlCol="0" anchor="ctr"/>
           <a:lstStyle/>
           <a:p>
-            <a:pPr marL="0" indent="0">
-              <a:buNone/>
-            </a:pPr>
             <a:r>
               <a:rPr lang="en-US" sz="1000" dirty="0">
                 <a:solidFill>
@@ -12774,9 +13112,7 @@
           <a:bodyPr wrap="square" lIns="0" tIns="0" rIns="0" bIns="0" rtlCol="0" anchor="ctr"/>
           <a:lstStyle/>
           <a:p>
-            <a:pPr marL="0" indent="0" algn="r">
-              <a:buNone/>
-            </a:pPr>
+            <a:pPr algn="r"/>
             <a:r>
               <a:rPr lang="en-US" sz="2000" b="1" dirty="0">
                 <a:solidFill>
@@ -12810,9 +13146,7 @@
           <a:bodyPr wrap="square" lIns="0" tIns="0" rIns="0" bIns="0" rtlCol="0" anchor="ctr"/>
           <a:lstStyle/>
           <a:p>
-            <a:pPr marL="0" indent="0" algn="r">
-              <a:buNone/>
-            </a:pPr>
+            <a:pPr algn="r"/>
             <a:r>
               <a:rPr lang="en-US" sz="900" dirty="0">
                 <a:solidFill>
@@ -12846,9 +13180,6 @@
           <a:bodyPr wrap="square" lIns="0" tIns="0" rIns="0" bIns="0" rtlCol="0" anchor="ctr"/>
           <a:lstStyle/>
           <a:p>
-            <a:pPr marL="0" indent="0">
-              <a:buNone/>
-            </a:pPr>
             <a:r>
               <a:rPr lang="en-US" sz="900" dirty="0">
                 <a:solidFill>
@@ -12921,9 +13252,6 @@
           <a:bodyPr wrap="square" lIns="0" tIns="0" rIns="0" bIns="0" rtlCol="0" anchor="ctr"/>
           <a:lstStyle/>
           <a:p>
-            <a:pPr marL="0" indent="0">
-              <a:buNone/>
-            </a:pPr>
             <a:r>
               <a:rPr lang="en-US" sz="1400" b="1" dirty="0">
                 <a:solidFill>
@@ -12957,9 +13285,6 @@
           <a:bodyPr wrap="square" lIns="0" tIns="0" rIns="0" bIns="0" rtlCol="0" anchor="ctr"/>
           <a:lstStyle/>
           <a:p>
-            <a:pPr marL="0" indent="0">
-              <a:buNone/>
-            </a:pPr>
             <a:r>
               <a:rPr lang="en-US" sz="1000" dirty="0">
                 <a:solidFill>
@@ -12993,9 +13318,7 @@
           <a:bodyPr wrap="square" lIns="0" tIns="0" rIns="0" bIns="0" rtlCol="0" anchor="ctr"/>
           <a:lstStyle/>
           <a:p>
-            <a:pPr marL="0" indent="0" algn="r">
-              <a:buNone/>
-            </a:pPr>
+            <a:pPr algn="r"/>
             <a:r>
               <a:rPr lang="en-US" sz="2000" b="1" dirty="0">
                 <a:solidFill>
@@ -13029,9 +13352,7 @@
           <a:bodyPr wrap="square" lIns="0" tIns="0" rIns="0" bIns="0" rtlCol="0" anchor="ctr"/>
           <a:lstStyle/>
           <a:p>
-            <a:pPr marL="0" indent="0" algn="r">
-              <a:buNone/>
-            </a:pPr>
+            <a:pPr algn="r"/>
             <a:r>
               <a:rPr lang="en-US" sz="900" dirty="0">
                 <a:solidFill>
@@ -13065,9 +13386,6 @@
           <a:bodyPr wrap="square" lIns="0" tIns="0" rIns="0" bIns="0" rtlCol="0" anchor="ctr"/>
           <a:lstStyle/>
           <a:p>
-            <a:pPr marL="0" indent="0">
-              <a:buNone/>
-            </a:pPr>
             <a:r>
               <a:rPr lang="en-US" sz="900" dirty="0">
                 <a:solidFill>
@@ -13101,9 +13419,7 @@
           <a:bodyPr wrap="square" lIns="0" tIns="0" rIns="0" bIns="0" rtlCol="0" anchor="ctr"/>
           <a:lstStyle/>
           <a:p>
-            <a:pPr marL="0" indent="0" algn="ctr">
-              <a:buNone/>
-            </a:pPr>
+            <a:pPr algn="ctr"/>
             <a:r>
               <a:rPr lang="en-US" sz="900" i="1" dirty="0">
                 <a:solidFill>
@@ -13169,9 +13485,6 @@
           <a:bodyPr wrap="square" lIns="0" tIns="0" rIns="0" bIns="0" rtlCol="0" anchor="ctr"/>
           <a:lstStyle/>
           <a:p>
-            <a:pPr marL="0" indent="0">
-              <a:buNone/>
-            </a:pPr>
             <a:r>
               <a:rPr lang="en-US" sz="950" i="1" dirty="0">
                 <a:solidFill>
@@ -13195,14 +13508,6 @@
 <file path=ppt/slides/slide9.xml><?xml version="1.0" encoding="utf-8"?>
 <p:sld xmlns:a="http://schemas.openxmlformats.org/drawingml/2006/main" xmlns:r="http://schemas.openxmlformats.org/officeDocument/2006/relationships" xmlns:p="http://schemas.openxmlformats.org/presentationml/2006/main">
   <p:cSld name="Slide 9">
-    <p:bg>
-      <p:bgPr>
-        <a:solidFill>
-          <a:srgbClr val="0D1B2A"/>
-        </a:solidFill>
-        <a:effectLst/>
-      </p:bgPr>
-    </p:bg>
     <p:spTree>
       <p:nvGrpSpPr>
         <p:cNvPr id="1" name=""/>
@@ -13265,9 +13570,6 @@
           <a:bodyPr wrap="square" lIns="0" tIns="0" rIns="0" bIns="0" rtlCol="0" anchor="ctr"/>
           <a:lstStyle/>
           <a:p>
-            <a:pPr marL="0" indent="0">
-              <a:buNone/>
-            </a:pPr>
             <a:r>
               <a:rPr lang="en-US" sz="1100" b="1" kern="0" spc="300" dirty="0">
                 <a:solidFill>
@@ -13301,9 +13603,6 @@
           <a:bodyPr wrap="square" lIns="0" tIns="0" rIns="0" bIns="0" rtlCol="0" anchor="ctr"/>
           <a:lstStyle/>
           <a:p>
-            <a:pPr marL="0" indent="0">
-              <a:buNone/>
-            </a:pPr>
             <a:r>
               <a:rPr lang="en-US" sz="2000" b="1" dirty="0">
                 <a:solidFill>
@@ -13337,9 +13636,6 @@
           <a:bodyPr wrap="square" lIns="0" tIns="0" rIns="0" bIns="0" rtlCol="0" anchor="ctr"/>
           <a:lstStyle/>
           <a:p>
-            <a:pPr marL="0" indent="0">
-              <a:buNone/>
-            </a:pPr>
             <a:r>
               <a:rPr lang="en-US" sz="850" i="1" dirty="0">
                 <a:solidFill>
@@ -13407,9 +13703,7 @@
           <a:bodyPr wrap="square" lIns="0" tIns="0" rIns="0" bIns="0" rtlCol="0" anchor="ctr"/>
           <a:lstStyle/>
           <a:p>
-            <a:pPr marL="0" indent="0" algn="ctr">
-              <a:buNone/>
-            </a:pPr>
+            <a:pPr algn="ctr"/>
             <a:r>
               <a:rPr lang="en-US" sz="4000" b="1" dirty="0">
                 <a:solidFill>
@@ -13443,9 +13737,7 @@
           <a:bodyPr wrap="square" lIns="0" tIns="0" rIns="0" bIns="0" rtlCol="0" anchor="ctr"/>
           <a:lstStyle/>
           <a:p>
-            <a:pPr marL="0" indent="0" algn="ctr">
-              <a:buNone/>
-            </a:pPr>
+            <a:pPr algn="ctr"/>
             <a:r>
               <a:rPr lang="en-US" sz="1100" b="1" dirty="0">
                 <a:solidFill>
@@ -13479,9 +13771,7 @@
           <a:bodyPr wrap="square" lIns="0" tIns="0" rIns="0" bIns="0" rtlCol="0" anchor="ctr"/>
           <a:lstStyle/>
           <a:p>
-            <a:pPr marL="0" indent="0" algn="ctr">
-              <a:buNone/>
-            </a:pPr>
+            <a:pPr algn="ctr"/>
             <a:r>
               <a:rPr lang="en-US" sz="900" dirty="0">
                 <a:solidFill>
@@ -13542,9 +13832,6 @@
           <a:bodyPr wrap="square" lIns="0" tIns="0" rIns="0" bIns="0" rtlCol="0" anchor="ctr"/>
           <a:lstStyle/>
           <a:p>
-            <a:pPr marL="0" indent="0">
-              <a:buNone/>
-            </a:pPr>
             <a:r>
               <a:rPr lang="en-US" sz="950" dirty="0">
                 <a:solidFill>
@@ -13578,9 +13865,6 @@
           <a:bodyPr wrap="square" lIns="0" tIns="0" rIns="0" bIns="0" rtlCol="0" anchor="ctr"/>
           <a:lstStyle/>
           <a:p>
-            <a:pPr marL="0" indent="0">
-              <a:buNone/>
-            </a:pPr>
             <a:r>
               <a:rPr lang="en-US" sz="950" dirty="0">
                 <a:solidFill>
@@ -13614,9 +13898,6 @@
           <a:bodyPr wrap="square" lIns="0" tIns="0" rIns="0" bIns="0" rtlCol="0" anchor="ctr"/>
           <a:lstStyle/>
           <a:p>
-            <a:pPr marL="0" indent="0">
-              <a:buNone/>
-            </a:pPr>
             <a:r>
               <a:rPr lang="en-US" sz="950" dirty="0">
                 <a:solidFill>
@@ -13650,9 +13931,6 @@
           <a:bodyPr wrap="square" lIns="0" tIns="0" rIns="0" bIns="0" rtlCol="0" anchor="ctr"/>
           <a:lstStyle/>
           <a:p>
-            <a:pPr marL="0" indent="0">
-              <a:buNone/>
-            </a:pPr>
             <a:r>
               <a:rPr lang="en-US" sz="950" dirty="0">
                 <a:solidFill>
@@ -13686,9 +13964,6 @@
           <a:bodyPr wrap="square" lIns="0" tIns="0" rIns="0" bIns="0" rtlCol="0" anchor="ctr"/>
           <a:lstStyle/>
           <a:p>
-            <a:pPr marL="0" indent="0">
-              <a:buNone/>
-            </a:pPr>
             <a:r>
               <a:rPr lang="en-US" sz="950" dirty="0">
                 <a:solidFill>
@@ -13722,9 +13997,6 @@
           <a:bodyPr wrap="square" lIns="0" tIns="0" rIns="0" bIns="0" rtlCol="0" anchor="ctr"/>
           <a:lstStyle/>
           <a:p>
-            <a:pPr marL="0" indent="0">
-              <a:buNone/>
-            </a:pPr>
             <a:r>
               <a:rPr lang="en-US" sz="950" dirty="0">
                 <a:solidFill>
@@ -13792,9 +14064,7 @@
           <a:bodyPr wrap="square" lIns="0" tIns="0" rIns="0" bIns="0" rtlCol="0" anchor="ctr"/>
           <a:lstStyle/>
           <a:p>
-            <a:pPr marL="0" indent="0" algn="ctr">
-              <a:buNone/>
-            </a:pPr>
+            <a:pPr algn="ctr"/>
             <a:r>
               <a:rPr lang="en-US" sz="4000" b="1" dirty="0">
                 <a:solidFill>
@@ -13828,9 +14098,7 @@
           <a:bodyPr wrap="square" lIns="0" tIns="0" rIns="0" bIns="0" rtlCol="0" anchor="ctr"/>
           <a:lstStyle/>
           <a:p>
-            <a:pPr marL="0" indent="0" algn="ctr">
-              <a:buNone/>
-            </a:pPr>
+            <a:pPr algn="ctr"/>
             <a:r>
               <a:rPr lang="en-US" sz="1100" b="1" dirty="0">
                 <a:solidFill>
@@ -13864,9 +14132,7 @@
           <a:bodyPr wrap="square" lIns="0" tIns="0" rIns="0" bIns="0" rtlCol="0" anchor="ctr"/>
           <a:lstStyle/>
           <a:p>
-            <a:pPr marL="0" indent="0" algn="ctr">
-              <a:buNone/>
-            </a:pPr>
+            <a:pPr algn="ctr"/>
             <a:r>
               <a:rPr lang="en-US" sz="900" dirty="0">
                 <a:solidFill>
@@ -13927,9 +14193,6 @@
           <a:bodyPr wrap="square" lIns="0" tIns="0" rIns="0" bIns="0" rtlCol="0" anchor="ctr"/>
           <a:lstStyle/>
           <a:p>
-            <a:pPr marL="0" indent="0">
-              <a:buNone/>
-            </a:pPr>
             <a:r>
               <a:rPr lang="en-US" sz="950" dirty="0">
                 <a:solidFill>
@@ -13963,9 +14226,6 @@
           <a:bodyPr wrap="square" lIns="0" tIns="0" rIns="0" bIns="0" rtlCol="0" anchor="ctr"/>
           <a:lstStyle/>
           <a:p>
-            <a:pPr marL="0" indent="0">
-              <a:buNone/>
-            </a:pPr>
             <a:r>
               <a:rPr lang="en-US" sz="950" dirty="0">
                 <a:solidFill>
@@ -13999,9 +14259,6 @@
           <a:bodyPr wrap="square" lIns="0" tIns="0" rIns="0" bIns="0" rtlCol="0" anchor="ctr"/>
           <a:lstStyle/>
           <a:p>
-            <a:pPr marL="0" indent="0">
-              <a:buNone/>
-            </a:pPr>
             <a:r>
               <a:rPr lang="en-US" sz="950" dirty="0">
                 <a:solidFill>
@@ -14035,9 +14292,6 @@
           <a:bodyPr wrap="square" lIns="0" tIns="0" rIns="0" bIns="0" rtlCol="0" anchor="ctr"/>
           <a:lstStyle/>
           <a:p>
-            <a:pPr marL="0" indent="0">
-              <a:buNone/>
-            </a:pPr>
             <a:r>
               <a:rPr lang="en-US" sz="950" dirty="0">
                 <a:solidFill>
@@ -14071,9 +14325,6 @@
           <a:bodyPr wrap="square" lIns="0" tIns="0" rIns="0" bIns="0" rtlCol="0" anchor="ctr"/>
           <a:lstStyle/>
           <a:p>
-            <a:pPr marL="0" indent="0">
-              <a:buNone/>
-            </a:pPr>
             <a:r>
               <a:rPr lang="en-US" sz="950" dirty="0">
                 <a:solidFill>
@@ -14141,9 +14392,7 @@
           <a:bodyPr wrap="square" lIns="0" tIns="0" rIns="0" bIns="0" rtlCol="0" anchor="ctr"/>
           <a:lstStyle/>
           <a:p>
-            <a:pPr marL="0" indent="0" algn="ctr">
-              <a:buNone/>
-            </a:pPr>
+            <a:pPr algn="ctr"/>
             <a:r>
               <a:rPr lang="en-US" sz="4000" b="1" dirty="0">
                 <a:solidFill>
@@ -14177,9 +14426,7 @@
           <a:bodyPr wrap="square" lIns="0" tIns="0" rIns="0" bIns="0" rtlCol="0" anchor="ctr"/>
           <a:lstStyle/>
           <a:p>
-            <a:pPr marL="0" indent="0" algn="ctr">
-              <a:buNone/>
-            </a:pPr>
+            <a:pPr algn="ctr"/>
             <a:r>
               <a:rPr lang="en-US" sz="1100" b="1" dirty="0">
                 <a:solidFill>
@@ -14213,9 +14460,7 @@
           <a:bodyPr wrap="square" lIns="0" tIns="0" rIns="0" bIns="0" rtlCol="0" anchor="ctr"/>
           <a:lstStyle/>
           <a:p>
-            <a:pPr marL="0" indent="0" algn="ctr">
-              <a:buNone/>
-            </a:pPr>
+            <a:pPr algn="ctr"/>
             <a:r>
               <a:rPr lang="en-US" sz="900" dirty="0">
                 <a:solidFill>
@@ -14276,9 +14521,6 @@
           <a:bodyPr wrap="square" lIns="0" tIns="0" rIns="0" bIns="0" rtlCol="0" anchor="ctr"/>
           <a:lstStyle/>
           <a:p>
-            <a:pPr marL="0" indent="0">
-              <a:buNone/>
-            </a:pPr>
             <a:r>
               <a:rPr lang="en-US" sz="950" dirty="0">
                 <a:solidFill>
@@ -14312,9 +14554,6 @@
           <a:bodyPr wrap="square" lIns="0" tIns="0" rIns="0" bIns="0" rtlCol="0" anchor="ctr"/>
           <a:lstStyle/>
           <a:p>
-            <a:pPr marL="0" indent="0">
-              <a:buNone/>
-            </a:pPr>
             <a:r>
               <a:rPr lang="en-US" sz="950" dirty="0">
                 <a:solidFill>
@@ -14348,9 +14587,6 @@
           <a:bodyPr wrap="square" lIns="0" tIns="0" rIns="0" bIns="0" rtlCol="0" anchor="ctr"/>
           <a:lstStyle/>
           <a:p>
-            <a:pPr marL="0" indent="0">
-              <a:buNone/>
-            </a:pPr>
             <a:r>
               <a:rPr lang="en-US" sz="950" dirty="0">
                 <a:solidFill>
@@ -14384,9 +14620,6 @@
           <a:bodyPr wrap="square" lIns="0" tIns="0" rIns="0" bIns="0" rtlCol="0" anchor="ctr"/>
           <a:lstStyle/>
           <a:p>
-            <a:pPr marL="0" indent="0">
-              <a:buNone/>
-            </a:pPr>
             <a:r>
               <a:rPr lang="en-US" sz="950" dirty="0">
                 <a:solidFill>
@@ -14420,9 +14653,6 @@
           <a:bodyPr wrap="square" lIns="0" tIns="0" rIns="0" bIns="0" rtlCol="0" anchor="ctr"/>
           <a:lstStyle/>
           <a:p>
-            <a:pPr marL="0" indent="0">
-              <a:buNone/>
-            </a:pPr>
             <a:r>
               <a:rPr lang="en-US" sz="950" dirty="0">
                 <a:solidFill>
@@ -14490,9 +14720,7 @@
           <a:bodyPr wrap="square" lIns="0" tIns="0" rIns="0" bIns="0" rtlCol="0" anchor="ctr"/>
           <a:lstStyle/>
           <a:p>
-            <a:pPr marL="0" indent="0" algn="ctr">
-              <a:buNone/>
-            </a:pPr>
+            <a:pPr algn="ctr"/>
             <a:r>
               <a:rPr lang="en-US" sz="4000" b="1" dirty="0">
                 <a:solidFill>
@@ -14526,9 +14754,7 @@
           <a:bodyPr wrap="square" lIns="0" tIns="0" rIns="0" bIns="0" rtlCol="0" anchor="ctr"/>
           <a:lstStyle/>
           <a:p>
-            <a:pPr marL="0" indent="0" algn="ctr">
-              <a:buNone/>
-            </a:pPr>
+            <a:pPr algn="ctr"/>
             <a:r>
               <a:rPr lang="en-US" sz="1100" b="1" dirty="0">
                 <a:solidFill>
@@ -14562,9 +14788,7 @@
           <a:bodyPr wrap="square" lIns="0" tIns="0" rIns="0" bIns="0" rtlCol="0" anchor="ctr"/>
           <a:lstStyle/>
           <a:p>
-            <a:pPr marL="0" indent="0" algn="ctr">
-              <a:buNone/>
-            </a:pPr>
+            <a:pPr algn="ctr"/>
             <a:r>
               <a:rPr lang="en-US" sz="900" dirty="0">
                 <a:solidFill>
@@ -14625,9 +14849,6 @@
           <a:bodyPr wrap="square" lIns="0" tIns="0" rIns="0" bIns="0" rtlCol="0" anchor="ctr"/>
           <a:lstStyle/>
           <a:p>
-            <a:pPr marL="0" indent="0">
-              <a:buNone/>
-            </a:pPr>
             <a:r>
               <a:rPr lang="en-US" sz="950" dirty="0">
                 <a:solidFill>
@@ -14661,9 +14882,6 @@
           <a:bodyPr wrap="square" lIns="0" tIns="0" rIns="0" bIns="0" rtlCol="0" anchor="ctr"/>
           <a:lstStyle/>
           <a:p>
-            <a:pPr marL="0" indent="0">
-              <a:buNone/>
-            </a:pPr>
             <a:r>
               <a:rPr lang="en-US" sz="950" dirty="0">
                 <a:solidFill>
@@ -14697,9 +14915,6 @@
           <a:bodyPr wrap="square" lIns="0" tIns="0" rIns="0" bIns="0" rtlCol="0" anchor="ctr"/>
           <a:lstStyle/>
           <a:p>
-            <a:pPr marL="0" indent="0">
-              <a:buNone/>
-            </a:pPr>
             <a:r>
               <a:rPr lang="en-US" sz="950" dirty="0">
                 <a:solidFill>
@@ -14733,9 +14948,6 @@
           <a:bodyPr wrap="square" lIns="0" tIns="0" rIns="0" bIns="0" rtlCol="0" anchor="ctr"/>
           <a:lstStyle/>
           <a:p>
-            <a:pPr marL="0" indent="0">
-              <a:buNone/>
-            </a:pPr>
             <a:r>
               <a:rPr lang="en-US" sz="950" dirty="0">
                 <a:solidFill>
@@ -14769,9 +14981,6 @@
           <a:bodyPr wrap="square" lIns="0" tIns="0" rIns="0" bIns="0" rtlCol="0" anchor="ctr"/>
           <a:lstStyle/>
           <a:p>
-            <a:pPr marL="0" indent="0">
-              <a:buNone/>
-            </a:pPr>
             <a:r>
               <a:rPr lang="en-US" sz="950" dirty="0">
                 <a:solidFill>

</xml_diff>